<commit_message>
Updates in duplication examples.
</commit_message>
<xml_diff>
--- a/duplicate-code.pptx
+++ b/duplicate-code.pptx
@@ -126,6 +126,22 @@
       </a:defRPr>
     </a:lvl9pPr>
   </p:defaultTextStyle>
+  <p:extLst>
+    <p:ext uri="{EFAFB233-063F-42B5-8137-9DF3F51BA10A}">
+      <p15:sldGuideLst xmlns:p15="http://schemas.microsoft.com/office/powerpoint/2012/main">
+        <p15:guide id="1" orient="horz" pos="2160">
+          <p15:clr>
+            <a:srgbClr val="A4A3A4"/>
+          </p15:clr>
+        </p15:guide>
+        <p15:guide id="2" pos="2880">
+          <p15:clr>
+            <a:srgbClr val="A4A3A4"/>
+          </p15:clr>
+        </p15:guide>
+      </p15:sldGuideLst>
+    </p:ext>
+  </p:extLst>
 </p:presentation>
 </file>
 
@@ -218,7 +234,7 @@
             <a:fld id="{56FF66BB-58F6-4A37-8208-0812DDE6C8EF}" type="datetimeFigureOut">
               <a:rPr lang="el-GR" smtClean="0"/>
               <a:pPr/>
-              <a:t>23/11/2023</a:t>
+              <a:t>25/11/2024</a:t>
             </a:fld>
             <a:endParaRPr lang="el-GR"/>
           </a:p>
@@ -292,6 +308,11 @@
         </p:txBody>
       </p:sp>
     </p:spTree>
+    <p:extLst>
+      <p:ext uri="{BB962C8B-B14F-4D97-AF65-F5344CB8AC3E}">
+        <p14:creationId xmlns:p14="http://schemas.microsoft.com/office/powerpoint/2010/main" val="1"/>
+      </p:ext>
+    </p:extLst>
   </p:cSld>
   <p:clrMap bg1="lt1" tx1="dk1" bg2="lt2" tx2="dk2" accent1="accent1" accent2="accent2" accent3="accent3" accent4="accent4" accent5="accent5" accent6="accent6" hlink="hlink" folHlink="folHlink"/>
 </p:handoutMaster>
@@ -380,7 +401,7 @@
             <a:fld id="{DC17DF70-03C8-4BDB-82BF-9C076E474B74}" type="datetimeFigureOut">
               <a:rPr lang="el-GR" smtClean="0"/>
               <a:pPr/>
-              <a:t>23/11/2023</a:t>
+              <a:t>25/11/2024</a:t>
             </a:fld>
             <a:endParaRPr lang="el-GR"/>
           </a:p>
@@ -446,35 +467,35 @@
           <a:p>
             <a:pPr lvl="0"/>
             <a:r>
-              <a:rPr lang="en-US" smtClean="0"/>
+              <a:rPr lang="en-US"/>
               <a:t>Click to edit Master text styles</a:t>
             </a:r>
           </a:p>
           <a:p>
             <a:pPr lvl="1"/>
             <a:r>
-              <a:rPr lang="en-US" smtClean="0"/>
+              <a:rPr lang="en-US"/>
               <a:t>Second level</a:t>
             </a:r>
           </a:p>
           <a:p>
             <a:pPr lvl="2"/>
             <a:r>
-              <a:rPr lang="en-US" smtClean="0"/>
+              <a:rPr lang="en-US"/>
               <a:t>Third level</a:t>
             </a:r>
           </a:p>
           <a:p>
             <a:pPr lvl="3"/>
             <a:r>
-              <a:rPr lang="en-US" smtClean="0"/>
+              <a:rPr lang="en-US"/>
               <a:t>Fourth level</a:t>
             </a:r>
           </a:p>
           <a:p>
             <a:pPr lvl="4"/>
             <a:r>
-              <a:rPr lang="en-US" smtClean="0"/>
+              <a:rPr lang="en-US"/>
               <a:t>Fifth level</a:t>
             </a:r>
             <a:endParaRPr lang="el-GR"/>
@@ -693,15 +714,15 @@
           <a:lstStyle/>
           <a:p>
             <a:r>
-              <a:rPr lang="en-US" dirty="0" smtClean="0"/>
+              <a:rPr lang="en-US" dirty="0"/>
               <a:t>Draw</a:t>
             </a:r>
             <a:r>
-              <a:rPr lang="en-US" baseline="0" dirty="0" smtClean="0"/>
+              <a:rPr lang="en-US" baseline="0" dirty="0"/>
               <a:t> figures to analyze </a:t>
             </a:r>
             <a:r>
-              <a:rPr lang="en-US" baseline="0" smtClean="0"/>
+              <a:rPr lang="en-US" baseline="0"/>
               <a:t>the stuff</a:t>
             </a:r>
             <a:endParaRPr lang="en-US"/>
@@ -871,7 +892,7 @@
           <a:bodyPr/>
           <a:lstStyle/>
           <a:p>
-            <a:endParaRPr lang="el-GR" smtClean="0"/>
+            <a:endParaRPr lang="el-GR"/>
           </a:p>
         </p:txBody>
       </p:sp>
@@ -897,7 +918,7 @@
               <a:pPr/>
               <a:t>14</a:t>
             </a:fld>
-            <a:endParaRPr lang="el-GR" smtClean="0"/>
+            <a:endParaRPr lang="el-GR"/>
           </a:p>
         </p:txBody>
       </p:sp>
@@ -958,7 +979,7 @@
           <a:bodyPr/>
           <a:lstStyle/>
           <a:p>
-            <a:endParaRPr lang="el-GR" smtClean="0"/>
+            <a:endParaRPr lang="el-GR"/>
           </a:p>
         </p:txBody>
       </p:sp>
@@ -984,7 +1005,7 @@
               <a:pPr/>
               <a:t>15</a:t>
             </a:fld>
-            <a:endParaRPr lang="el-GR" smtClean="0"/>
+            <a:endParaRPr lang="el-GR"/>
           </a:p>
         </p:txBody>
       </p:sp>
@@ -1042,10 +1063,9 @@
           </a:lstStyle>
           <a:p>
             <a:r>
-              <a:rPr kumimoji="0" lang="en-US" smtClean="0"/>
+              <a:rPr kumimoji="0" lang="en-US"/>
               <a:t>Click to edit Master title style</a:t>
             </a:r>
-            <a:endParaRPr kumimoji="0" lang="en-US"/>
           </a:p>
         </p:txBody>
       </p:sp>
@@ -1106,10 +1126,9 @@
           </a:lstStyle>
           <a:p>
             <a:r>
-              <a:rPr kumimoji="0" lang="en-US" smtClean="0"/>
+              <a:rPr kumimoji="0" lang="en-US"/>
               <a:t>Click to edit Master subtitle style</a:t>
             </a:r>
-            <a:endParaRPr kumimoji="0" lang="en-US"/>
           </a:p>
         </p:txBody>
       </p:sp>
@@ -1140,7 +1159,7 @@
             <a:fld id="{1D8BD707-D9CF-40AE-B4C6-C98DA3205C09}" type="datetimeFigureOut">
               <a:rPr lang="en-US" smtClean="0"/>
               <a:pPr/>
-              <a:t>11/23/2023</a:t>
+              <a:t>11/25/2024</a:t>
             </a:fld>
             <a:endParaRPr lang="en-US"/>
           </a:p>
@@ -1424,10 +1443,9 @@
           <a:lstStyle/>
           <a:p>
             <a:r>
-              <a:rPr kumimoji="0" lang="en-US" smtClean="0"/>
+              <a:rPr kumimoji="0" lang="en-US"/>
               <a:t>Click to edit Master title style</a:t>
             </a:r>
-            <a:endParaRPr kumimoji="0" lang="en-US"/>
           </a:p>
         </p:txBody>
       </p:sp>
@@ -1448,35 +1466,35 @@
           <a:p>
             <a:pPr lvl="0" eaLnBrk="1" latinLnBrk="0" hangingPunct="1"/>
             <a:r>
-              <a:rPr lang="en-US" smtClean="0"/>
+              <a:rPr lang="en-US"/>
               <a:t>Click to edit Master text styles</a:t>
             </a:r>
           </a:p>
           <a:p>
             <a:pPr lvl="1" eaLnBrk="1" latinLnBrk="0" hangingPunct="1"/>
             <a:r>
-              <a:rPr lang="en-US" smtClean="0"/>
+              <a:rPr lang="en-US"/>
               <a:t>Second level</a:t>
             </a:r>
           </a:p>
           <a:p>
             <a:pPr lvl="2" eaLnBrk="1" latinLnBrk="0" hangingPunct="1"/>
             <a:r>
-              <a:rPr lang="en-US" smtClean="0"/>
+              <a:rPr lang="en-US"/>
               <a:t>Third level</a:t>
             </a:r>
           </a:p>
           <a:p>
             <a:pPr lvl="3" eaLnBrk="1" latinLnBrk="0" hangingPunct="1"/>
             <a:r>
-              <a:rPr lang="en-US" smtClean="0"/>
+              <a:rPr lang="en-US"/>
               <a:t>Fourth level</a:t>
             </a:r>
           </a:p>
           <a:p>
             <a:pPr lvl="4" eaLnBrk="1" latinLnBrk="0" hangingPunct="1"/>
             <a:r>
-              <a:rPr lang="en-US" smtClean="0"/>
+              <a:rPr lang="en-US"/>
               <a:t>Fifth level</a:t>
             </a:r>
             <a:endParaRPr kumimoji="0" lang="en-US"/>
@@ -1501,7 +1519,7 @@
             <a:fld id="{1D8BD707-D9CF-40AE-B4C6-C98DA3205C09}" type="datetimeFigureOut">
               <a:rPr lang="en-US" smtClean="0"/>
               <a:pPr/>
-              <a:t>11/23/2023</a:t>
+              <a:t>11/25/2024</a:t>
             </a:fld>
             <a:endParaRPr lang="en-US"/>
           </a:p>
@@ -1596,10 +1614,9 @@
           <a:lstStyle/>
           <a:p>
             <a:r>
-              <a:rPr kumimoji="0" lang="en-US" smtClean="0"/>
+              <a:rPr kumimoji="0" lang="en-US"/>
               <a:t>Click to edit Master title style</a:t>
             </a:r>
-            <a:endParaRPr kumimoji="0" lang="en-US"/>
           </a:p>
         </p:txBody>
       </p:sp>
@@ -1625,35 +1642,35 @@
           <a:p>
             <a:pPr lvl="0" eaLnBrk="1" latinLnBrk="0" hangingPunct="1"/>
             <a:r>
-              <a:rPr lang="en-US" smtClean="0"/>
+              <a:rPr lang="en-US"/>
               <a:t>Click to edit Master text styles</a:t>
             </a:r>
           </a:p>
           <a:p>
             <a:pPr lvl="1" eaLnBrk="1" latinLnBrk="0" hangingPunct="1"/>
             <a:r>
-              <a:rPr lang="en-US" smtClean="0"/>
+              <a:rPr lang="en-US"/>
               <a:t>Second level</a:t>
             </a:r>
           </a:p>
           <a:p>
             <a:pPr lvl="2" eaLnBrk="1" latinLnBrk="0" hangingPunct="1"/>
             <a:r>
-              <a:rPr lang="en-US" smtClean="0"/>
+              <a:rPr lang="en-US"/>
               <a:t>Third level</a:t>
             </a:r>
           </a:p>
           <a:p>
             <a:pPr lvl="3" eaLnBrk="1" latinLnBrk="0" hangingPunct="1"/>
             <a:r>
-              <a:rPr lang="en-US" smtClean="0"/>
+              <a:rPr lang="en-US"/>
               <a:t>Fourth level</a:t>
             </a:r>
           </a:p>
           <a:p>
             <a:pPr lvl="4" eaLnBrk="1" latinLnBrk="0" hangingPunct="1"/>
             <a:r>
-              <a:rPr lang="en-US" smtClean="0"/>
+              <a:rPr lang="en-US"/>
               <a:t>Fifth level</a:t>
             </a:r>
             <a:endParaRPr kumimoji="0" lang="en-US"/>
@@ -1678,7 +1695,7 @@
             <a:fld id="{1D8BD707-D9CF-40AE-B4C6-C98DA3205C09}" type="datetimeFigureOut">
               <a:rPr lang="en-US" smtClean="0"/>
               <a:pPr/>
-              <a:t>11/23/2023</a:t>
+              <a:t>11/25/2024</a:t>
             </a:fld>
             <a:endParaRPr lang="en-US"/>
           </a:p>
@@ -1890,10 +1907,9 @@
           <a:lstStyle/>
           <a:p>
             <a:r>
-              <a:rPr kumimoji="0" lang="en-US" smtClean="0"/>
+              <a:rPr kumimoji="0" lang="en-US"/>
               <a:t>Click to edit Master title style</a:t>
             </a:r>
-            <a:endParaRPr kumimoji="0" lang="en-US"/>
           </a:p>
         </p:txBody>
       </p:sp>
@@ -1915,7 +1931,7 @@
             <a:fld id="{1D8BD707-D9CF-40AE-B4C6-C98DA3205C09}" type="datetimeFigureOut">
               <a:rPr lang="en-US" smtClean="0"/>
               <a:pPr/>
-              <a:t>11/23/2023</a:t>
+              <a:t>11/25/2024</a:t>
             </a:fld>
             <a:endParaRPr lang="en-US"/>
           </a:p>
@@ -1986,35 +2002,35 @@
           <a:p>
             <a:pPr lvl="0" eaLnBrk="1" latinLnBrk="0" hangingPunct="1"/>
             <a:r>
-              <a:rPr lang="en-US" smtClean="0"/>
+              <a:rPr lang="en-US"/>
               <a:t>Click to edit Master text styles</a:t>
             </a:r>
           </a:p>
           <a:p>
             <a:pPr lvl="1" eaLnBrk="1" latinLnBrk="0" hangingPunct="1"/>
             <a:r>
-              <a:rPr lang="en-US" smtClean="0"/>
+              <a:rPr lang="en-US"/>
               <a:t>Second level</a:t>
             </a:r>
           </a:p>
           <a:p>
             <a:pPr lvl="2" eaLnBrk="1" latinLnBrk="0" hangingPunct="1"/>
             <a:r>
-              <a:rPr lang="en-US" smtClean="0"/>
+              <a:rPr lang="en-US"/>
               <a:t>Third level</a:t>
             </a:r>
           </a:p>
           <a:p>
             <a:pPr lvl="3" eaLnBrk="1" latinLnBrk="0" hangingPunct="1"/>
             <a:r>
-              <a:rPr lang="en-US" smtClean="0"/>
+              <a:rPr lang="en-US"/>
               <a:t>Fourth level</a:t>
             </a:r>
           </a:p>
           <a:p>
             <a:pPr lvl="4" eaLnBrk="1" latinLnBrk="0" hangingPunct="1"/>
             <a:r>
-              <a:rPr lang="en-US" smtClean="0"/>
+              <a:rPr lang="en-US"/>
               <a:t>Fifth level</a:t>
             </a:r>
             <a:endParaRPr kumimoji="0" lang="en-US"/>
@@ -2072,10 +2088,9 @@
           </a:lstStyle>
           <a:p>
             <a:r>
-              <a:rPr kumimoji="0" lang="en-US" smtClean="0"/>
+              <a:rPr kumimoji="0" lang="en-US"/>
               <a:t>Click to edit Master title style</a:t>
             </a:r>
-            <a:endParaRPr kumimoji="0" lang="en-US"/>
           </a:p>
         </p:txBody>
       </p:sp>
@@ -2152,7 +2167,7 @@
           <a:p>
             <a:pPr lvl="0" eaLnBrk="1" latinLnBrk="0" hangingPunct="1"/>
             <a:r>
-              <a:rPr kumimoji="0" lang="en-US" smtClean="0"/>
+              <a:rPr kumimoji="0" lang="en-US"/>
               <a:t>Click to edit Master text styles</a:t>
             </a:r>
           </a:p>
@@ -2181,7 +2196,7 @@
             <a:fld id="{1D8BD707-D9CF-40AE-B4C6-C98DA3205C09}" type="datetimeFigureOut">
               <a:rPr lang="en-US" smtClean="0"/>
               <a:pPr/>
-              <a:t>11/23/2023</a:t>
+              <a:t>11/25/2024</a:t>
             </a:fld>
             <a:endParaRPr lang="en-US"/>
           </a:p>
@@ -2378,10 +2393,9 @@
           <a:lstStyle/>
           <a:p>
             <a:r>
-              <a:rPr kumimoji="0" lang="en-US" smtClean="0"/>
+              <a:rPr kumimoji="0" lang="en-US"/>
               <a:t>Click to edit Master title style</a:t>
             </a:r>
-            <a:endParaRPr kumimoji="0" lang="en-US"/>
           </a:p>
         </p:txBody>
       </p:sp>
@@ -2403,7 +2417,7 @@
             <a:fld id="{1D8BD707-D9CF-40AE-B4C6-C98DA3205C09}" type="datetimeFigureOut">
               <a:rPr lang="en-US" smtClean="0"/>
               <a:pPr/>
-              <a:t>11/23/2023</a:t>
+              <a:t>11/25/2024</a:t>
             </a:fld>
             <a:endParaRPr lang="en-US"/>
           </a:p>
@@ -2474,35 +2488,35 @@
           <a:p>
             <a:pPr lvl="0" eaLnBrk="1" latinLnBrk="0" hangingPunct="1"/>
             <a:r>
-              <a:rPr lang="en-US" smtClean="0"/>
+              <a:rPr lang="en-US"/>
               <a:t>Click to edit Master text styles</a:t>
             </a:r>
           </a:p>
           <a:p>
             <a:pPr lvl="1" eaLnBrk="1" latinLnBrk="0" hangingPunct="1"/>
             <a:r>
-              <a:rPr lang="en-US" smtClean="0"/>
+              <a:rPr lang="en-US"/>
               <a:t>Second level</a:t>
             </a:r>
           </a:p>
           <a:p>
             <a:pPr lvl="2" eaLnBrk="1" latinLnBrk="0" hangingPunct="1"/>
             <a:r>
-              <a:rPr lang="en-US" smtClean="0"/>
+              <a:rPr lang="en-US"/>
               <a:t>Third level</a:t>
             </a:r>
           </a:p>
           <a:p>
             <a:pPr lvl="3" eaLnBrk="1" latinLnBrk="0" hangingPunct="1"/>
             <a:r>
-              <a:rPr lang="en-US" smtClean="0"/>
+              <a:rPr lang="en-US"/>
               <a:t>Fourth level</a:t>
             </a:r>
           </a:p>
           <a:p>
             <a:pPr lvl="4" eaLnBrk="1" latinLnBrk="0" hangingPunct="1"/>
             <a:r>
-              <a:rPr lang="en-US" smtClean="0"/>
+              <a:rPr lang="en-US"/>
               <a:t>Fifth level</a:t>
             </a:r>
             <a:endParaRPr kumimoji="0" lang="en-US"/>
@@ -2531,35 +2545,35 @@
           <a:p>
             <a:pPr lvl="0" eaLnBrk="1" latinLnBrk="0" hangingPunct="1"/>
             <a:r>
-              <a:rPr lang="en-US" smtClean="0"/>
+              <a:rPr lang="en-US"/>
               <a:t>Click to edit Master text styles</a:t>
             </a:r>
           </a:p>
           <a:p>
             <a:pPr lvl="1" eaLnBrk="1" latinLnBrk="0" hangingPunct="1"/>
             <a:r>
-              <a:rPr lang="en-US" smtClean="0"/>
+              <a:rPr lang="en-US"/>
               <a:t>Second level</a:t>
             </a:r>
           </a:p>
           <a:p>
             <a:pPr lvl="2" eaLnBrk="1" latinLnBrk="0" hangingPunct="1"/>
             <a:r>
-              <a:rPr lang="en-US" smtClean="0"/>
+              <a:rPr lang="en-US"/>
               <a:t>Third level</a:t>
             </a:r>
           </a:p>
           <a:p>
             <a:pPr lvl="3" eaLnBrk="1" latinLnBrk="0" hangingPunct="1"/>
             <a:r>
-              <a:rPr lang="en-US" smtClean="0"/>
+              <a:rPr lang="en-US"/>
               <a:t>Fourth level</a:t>
             </a:r>
           </a:p>
           <a:p>
             <a:pPr lvl="4" eaLnBrk="1" latinLnBrk="0" hangingPunct="1"/>
             <a:r>
-              <a:rPr lang="en-US" smtClean="0"/>
+              <a:rPr lang="en-US"/>
               <a:t>Fifth level</a:t>
             </a:r>
             <a:endParaRPr kumimoji="0" lang="en-US"/>
@@ -2616,10 +2630,9 @@
           </a:lstStyle>
           <a:p>
             <a:r>
-              <a:rPr kumimoji="0" lang="en-US" smtClean="0"/>
+              <a:rPr kumimoji="0" lang="en-US"/>
               <a:t>Click to edit Master title style</a:t>
             </a:r>
-            <a:endParaRPr kumimoji="0" lang="en-US"/>
           </a:p>
         </p:txBody>
       </p:sp>
@@ -2676,7 +2689,7 @@
           <a:p>
             <a:pPr lvl="0" eaLnBrk="1" latinLnBrk="0" hangingPunct="1"/>
             <a:r>
-              <a:rPr kumimoji="0" lang="en-US" smtClean="0"/>
+              <a:rPr kumimoji="0" lang="en-US"/>
               <a:t>Click to edit Master text styles</a:t>
             </a:r>
           </a:p>
@@ -2733,7 +2746,7 @@
           <a:p>
             <a:pPr lvl="0" eaLnBrk="1" latinLnBrk="0" hangingPunct="1"/>
             <a:r>
-              <a:rPr kumimoji="0" lang="en-US" smtClean="0"/>
+              <a:rPr kumimoji="0" lang="en-US"/>
               <a:t>Click to edit Master text styles</a:t>
             </a:r>
           </a:p>
@@ -2757,7 +2770,7 @@
             <a:fld id="{1D8BD707-D9CF-40AE-B4C6-C98DA3205C09}" type="datetimeFigureOut">
               <a:rPr lang="en-US" smtClean="0"/>
               <a:pPr/>
-              <a:t>11/23/2023</a:t>
+              <a:t>11/25/2024</a:t>
             </a:fld>
             <a:endParaRPr lang="en-US"/>
           </a:p>
@@ -2828,35 +2841,35 @@
           <a:p>
             <a:pPr lvl="0" eaLnBrk="1" latinLnBrk="0" hangingPunct="1"/>
             <a:r>
-              <a:rPr lang="en-US" smtClean="0"/>
+              <a:rPr lang="en-US"/>
               <a:t>Click to edit Master text styles</a:t>
             </a:r>
           </a:p>
           <a:p>
             <a:pPr lvl="1" eaLnBrk="1" latinLnBrk="0" hangingPunct="1"/>
             <a:r>
-              <a:rPr lang="en-US" smtClean="0"/>
+              <a:rPr lang="en-US"/>
               <a:t>Second level</a:t>
             </a:r>
           </a:p>
           <a:p>
             <a:pPr lvl="2" eaLnBrk="1" latinLnBrk="0" hangingPunct="1"/>
             <a:r>
-              <a:rPr lang="en-US" smtClean="0"/>
+              <a:rPr lang="en-US"/>
               <a:t>Third level</a:t>
             </a:r>
           </a:p>
           <a:p>
             <a:pPr lvl="3" eaLnBrk="1" latinLnBrk="0" hangingPunct="1"/>
             <a:r>
-              <a:rPr lang="en-US" smtClean="0"/>
+              <a:rPr lang="en-US"/>
               <a:t>Fourth level</a:t>
             </a:r>
           </a:p>
           <a:p>
             <a:pPr lvl="4" eaLnBrk="1" latinLnBrk="0" hangingPunct="1"/>
             <a:r>
-              <a:rPr lang="en-US" smtClean="0"/>
+              <a:rPr lang="en-US"/>
               <a:t>Fifth level</a:t>
             </a:r>
             <a:endParaRPr kumimoji="0" lang="en-US"/>
@@ -2885,35 +2898,35 @@
           <a:p>
             <a:pPr lvl="0" eaLnBrk="1" latinLnBrk="0" hangingPunct="1"/>
             <a:r>
-              <a:rPr lang="en-US" smtClean="0"/>
+              <a:rPr lang="en-US"/>
               <a:t>Click to edit Master text styles</a:t>
             </a:r>
           </a:p>
           <a:p>
             <a:pPr lvl="1" eaLnBrk="1" latinLnBrk="0" hangingPunct="1"/>
             <a:r>
-              <a:rPr lang="en-US" smtClean="0"/>
+              <a:rPr lang="en-US"/>
               <a:t>Second level</a:t>
             </a:r>
           </a:p>
           <a:p>
             <a:pPr lvl="2" eaLnBrk="1" latinLnBrk="0" hangingPunct="1"/>
             <a:r>
-              <a:rPr lang="en-US" smtClean="0"/>
+              <a:rPr lang="en-US"/>
               <a:t>Third level</a:t>
             </a:r>
           </a:p>
           <a:p>
             <a:pPr lvl="3" eaLnBrk="1" latinLnBrk="0" hangingPunct="1"/>
             <a:r>
-              <a:rPr lang="en-US" smtClean="0"/>
+              <a:rPr lang="en-US"/>
               <a:t>Fourth level</a:t>
             </a:r>
           </a:p>
           <a:p>
             <a:pPr lvl="4" eaLnBrk="1" latinLnBrk="0" hangingPunct="1"/>
             <a:r>
-              <a:rPr lang="en-US" smtClean="0"/>
+              <a:rPr lang="en-US"/>
               <a:t>Fifth level</a:t>
             </a:r>
             <a:endParaRPr kumimoji="0" lang="en-US"/>
@@ -2966,10 +2979,9 @@
           <a:lstStyle/>
           <a:p>
             <a:r>
-              <a:rPr kumimoji="0" lang="en-US" smtClean="0"/>
+              <a:rPr kumimoji="0" lang="en-US"/>
               <a:t>Click to edit Master title style</a:t>
             </a:r>
-            <a:endParaRPr kumimoji="0" lang="en-US"/>
           </a:p>
         </p:txBody>
       </p:sp>
@@ -2991,7 +3003,7 @@
             <a:fld id="{1D8BD707-D9CF-40AE-B4C6-C98DA3205C09}" type="datetimeFigureOut">
               <a:rPr lang="en-US" smtClean="0"/>
               <a:pPr/>
-              <a:t>11/23/2023</a:t>
+              <a:t>11/25/2024</a:t>
             </a:fld>
             <a:endParaRPr lang="en-US"/>
           </a:p>
@@ -3133,7 +3145,7 @@
             <a:fld id="{1D8BD707-D9CF-40AE-B4C6-C98DA3205C09}" type="datetimeFigureOut">
               <a:rPr lang="en-US" smtClean="0"/>
               <a:pPr/>
-              <a:t>11/23/2023</a:t>
+              <a:t>11/25/2024</a:t>
             </a:fld>
             <a:endParaRPr lang="en-US"/>
           </a:p>
@@ -3328,10 +3340,9 @@
           </a:lstStyle>
           <a:p>
             <a:r>
-              <a:rPr kumimoji="0" lang="en-US" smtClean="0"/>
+              <a:rPr kumimoji="0" lang="en-US"/>
               <a:t>Click to edit Master title style</a:t>
             </a:r>
-            <a:endParaRPr kumimoji="0" lang="en-US"/>
           </a:p>
         </p:txBody>
       </p:sp>
@@ -3388,7 +3399,7 @@
           <a:p>
             <a:pPr lvl="0" eaLnBrk="1" latinLnBrk="0" hangingPunct="1"/>
             <a:r>
-              <a:rPr kumimoji="0" lang="en-US" smtClean="0"/>
+              <a:rPr kumimoji="0" lang="en-US"/>
               <a:t>Click to edit Master text styles</a:t>
             </a:r>
           </a:p>
@@ -3412,7 +3423,7 @@
             <a:fld id="{1D8BD707-D9CF-40AE-B4C6-C98DA3205C09}" type="datetimeFigureOut">
               <a:rPr lang="en-US" smtClean="0"/>
               <a:pPr/>
-              <a:t>11/23/2023</a:t>
+              <a:t>11/25/2024</a:t>
             </a:fld>
             <a:endParaRPr lang="en-US"/>
           </a:p>
@@ -3605,35 +3616,35 @@
           <a:p>
             <a:pPr lvl="0" eaLnBrk="1" latinLnBrk="0" hangingPunct="1"/>
             <a:r>
-              <a:rPr lang="en-US" smtClean="0"/>
+              <a:rPr lang="en-US"/>
               <a:t>Click to edit Master text styles</a:t>
             </a:r>
           </a:p>
           <a:p>
             <a:pPr lvl="1" eaLnBrk="1" latinLnBrk="0" hangingPunct="1"/>
             <a:r>
-              <a:rPr lang="en-US" smtClean="0"/>
+              <a:rPr lang="en-US"/>
               <a:t>Second level</a:t>
             </a:r>
           </a:p>
           <a:p>
             <a:pPr lvl="2" eaLnBrk="1" latinLnBrk="0" hangingPunct="1"/>
             <a:r>
-              <a:rPr lang="en-US" smtClean="0"/>
+              <a:rPr lang="en-US"/>
               <a:t>Third level</a:t>
             </a:r>
           </a:p>
           <a:p>
             <a:pPr lvl="3" eaLnBrk="1" latinLnBrk="0" hangingPunct="1"/>
             <a:r>
-              <a:rPr lang="en-US" smtClean="0"/>
+              <a:rPr lang="en-US"/>
               <a:t>Fourth level</a:t>
             </a:r>
           </a:p>
           <a:p>
             <a:pPr lvl="4" eaLnBrk="1" latinLnBrk="0" hangingPunct="1"/>
             <a:r>
-              <a:rPr lang="en-US" smtClean="0"/>
+              <a:rPr lang="en-US"/>
               <a:t>Fifth level</a:t>
             </a:r>
             <a:endParaRPr kumimoji="0" lang="en-US"/>
@@ -3700,10 +3711,9 @@
           </a:lstStyle>
           <a:p>
             <a:r>
-              <a:rPr kumimoji="0" lang="en-US" smtClean="0"/>
+              <a:rPr kumimoji="0" lang="en-US"/>
               <a:t>Click to edit Master title style</a:t>
             </a:r>
-            <a:endParaRPr kumimoji="0" lang="en-US"/>
           </a:p>
         </p:txBody>
       </p:sp>
@@ -3745,7 +3755,7 @@
           </a:lstStyle>
           <a:p>
             <a:r>
-              <a:rPr kumimoji="0" lang="en-US" smtClean="0"/>
+              <a:rPr kumimoji="0" lang="en-US"/>
               <a:t>Click icon to add picture</a:t>
             </a:r>
             <a:endParaRPr kumimoji="0" lang="en-US" dirty="0"/>
@@ -3792,7 +3802,7 @@
           <a:p>
             <a:pPr lvl="0" eaLnBrk="1" latinLnBrk="0" hangingPunct="1"/>
             <a:r>
-              <a:rPr kumimoji="0" lang="en-US" smtClean="0"/>
+              <a:rPr kumimoji="0" lang="en-US"/>
               <a:t>Click to edit Master text styles</a:t>
             </a:r>
           </a:p>
@@ -3816,7 +3826,7 @@
             <a:fld id="{1D8BD707-D9CF-40AE-B4C6-C98DA3205C09}" type="datetimeFigureOut">
               <a:rPr lang="en-US" smtClean="0"/>
               <a:pPr/>
-              <a:t>11/23/2023</a:t>
+              <a:t>11/25/2024</a:t>
             </a:fld>
             <a:endParaRPr lang="en-US"/>
           </a:p>
@@ -4053,10 +4063,9 @@
           <a:lstStyle/>
           <a:p>
             <a:r>
-              <a:rPr kumimoji="0" lang="en-US" smtClean="0"/>
+              <a:rPr kumimoji="0" lang="en-US"/>
               <a:t>Click to edit Master title style</a:t>
             </a:r>
-            <a:endParaRPr kumimoji="0" lang="en-US"/>
           </a:p>
         </p:txBody>
       </p:sp>
@@ -4087,38 +4096,37 @@
           <a:p>
             <a:pPr lvl="0" eaLnBrk="1" latinLnBrk="0" hangingPunct="1"/>
             <a:r>
-              <a:rPr kumimoji="0" lang="en-US" smtClean="0"/>
+              <a:rPr kumimoji="0" lang="en-US"/>
               <a:t>Click to edit Master text styles</a:t>
             </a:r>
           </a:p>
           <a:p>
             <a:pPr lvl="1" eaLnBrk="1" latinLnBrk="0" hangingPunct="1"/>
             <a:r>
-              <a:rPr kumimoji="0" lang="en-US" smtClean="0"/>
+              <a:rPr kumimoji="0" lang="en-US"/>
               <a:t>Second level</a:t>
             </a:r>
           </a:p>
           <a:p>
             <a:pPr lvl="2" eaLnBrk="1" latinLnBrk="0" hangingPunct="1"/>
             <a:r>
-              <a:rPr kumimoji="0" lang="en-US" smtClean="0"/>
+              <a:rPr kumimoji="0" lang="en-US"/>
               <a:t>Third level</a:t>
             </a:r>
           </a:p>
           <a:p>
             <a:pPr lvl="3" eaLnBrk="1" latinLnBrk="0" hangingPunct="1"/>
             <a:r>
-              <a:rPr kumimoji="0" lang="en-US" smtClean="0"/>
+              <a:rPr kumimoji="0" lang="en-US"/>
               <a:t>Fourth level</a:t>
             </a:r>
           </a:p>
           <a:p>
             <a:pPr lvl="4" eaLnBrk="1" latinLnBrk="0" hangingPunct="1"/>
             <a:r>
-              <a:rPr kumimoji="0" lang="en-US" smtClean="0"/>
+              <a:rPr kumimoji="0" lang="en-US"/>
               <a:t>Fifth level</a:t>
             </a:r>
-            <a:endParaRPr kumimoji="0" lang="en-US"/>
           </a:p>
         </p:txBody>
       </p:sp>
@@ -4156,7 +4164,7 @@
             <a:fld id="{1D8BD707-D9CF-40AE-B4C6-C98DA3205C09}" type="datetimeFigureOut">
               <a:rPr lang="en-US" smtClean="0"/>
               <a:pPr/>
-              <a:t>11/23/2023</a:t>
+              <a:t>11/25/2024</a:t>
             </a:fld>
             <a:endParaRPr lang="en-US"/>
           </a:p>
@@ -4737,20 +4745,20 @@
           <a:lstStyle/>
           <a:p>
             <a:r>
-              <a:rPr lang="en-US" dirty="0" smtClean="0"/>
+              <a:rPr lang="en-US" dirty="0"/>
               <a:t>Duplication</a:t>
             </a:r>
             <a:br>
-              <a:rPr lang="en-US" dirty="0" smtClean="0"/>
+              <a:rPr lang="en-US" dirty="0"/>
             </a:br>
             <a:r>
-              <a:rPr lang="en-US" sz="1800" dirty="0" smtClean="0">
+              <a:rPr lang="en-US" sz="1800" dirty="0">
                 <a:hlinkClick r:id="rId4"/>
               </a:rPr>
               <a:t>www.cs.uoi.gr/~zarras/soft-devII.htm</a:t>
             </a:r>
             <a:r>
-              <a:rPr lang="en-US" sz="1800" dirty="0" smtClean="0"/>
+              <a:rPr lang="en-US" sz="1800" dirty="0"/>
               <a:t>    </a:t>
             </a:r>
             <a:endParaRPr lang="el-GR" sz="1800" dirty="0"/>
@@ -4775,21 +4783,21 @@
           <a:lstStyle/>
           <a:p>
             <a:r>
-              <a:rPr lang="en-US" dirty="0" smtClean="0"/>
+              <a:rPr lang="en-US" dirty="0"/>
               <a:t>Sources: M. Fowler </a:t>
             </a:r>
             <a:r>
-              <a:rPr lang="en-US" dirty="0" err="1" smtClean="0"/>
+              <a:rPr lang="en-US" dirty="0" err="1"/>
               <a:t>Refactorings</a:t>
             </a:r>
             <a:r>
-              <a:rPr lang="en-US" dirty="0" smtClean="0"/>
+              <a:rPr lang="en-US" dirty="0"/>
               <a:t> Catalog</a:t>
             </a:r>
           </a:p>
           <a:p>
             <a:r>
-              <a:rPr lang="en-US" dirty="0" smtClean="0"/>
+              <a:rPr lang="en-US" dirty="0"/>
               <a:t>W. Wake Refactoring Workbook</a:t>
             </a:r>
             <a:endParaRPr lang="el-GR" dirty="0"/>
@@ -4801,13 +4809,6 @@
   <p:clrMapOvr>
     <a:masterClrMapping/>
   </p:clrMapOvr>
-  <p:timing>
-    <p:tnLst>
-      <p:par>
-        <p:cTn id="1" dur="indefinite" restart="never" nodeType="tmRoot"/>
-      </p:par>
-    </p:tnLst>
-  </p:timing>
 </p:sld>
 </file>
 
@@ -4844,10 +4845,10 @@
           <a:lstStyle/>
           <a:p>
             <a:r>
-              <a:rPr lang="en-US" smtClean="0"/>
+              <a:rPr lang="en-US"/>
               <a:t>Pull Up Field</a:t>
             </a:r>
-            <a:endParaRPr lang="el-GR" smtClean="0"/>
+            <a:endParaRPr lang="el-GR"/>
           </a:p>
         </p:txBody>
       </p:sp>
@@ -4874,11 +4875,11 @@
           <a:p>
             <a:pPr algn="just"/>
             <a:r>
-              <a:rPr lang="en-US" dirty="0" smtClean="0"/>
+              <a:rPr lang="en-US" dirty="0"/>
               <a:t>If </a:t>
             </a:r>
             <a:r>
-              <a:rPr lang="en-US" dirty="0" smtClean="0">
+              <a:rPr lang="en-US" dirty="0">
                 <a:solidFill>
                   <a:srgbClr val="FF0000"/>
                 </a:solidFill>
@@ -4886,11 +4887,11 @@
               <a:t>subclasses</a:t>
             </a:r>
             <a:r>
-              <a:rPr lang="en-US" dirty="0" smtClean="0"/>
+              <a:rPr lang="en-US" dirty="0"/>
               <a:t> are developed </a:t>
             </a:r>
             <a:r>
-              <a:rPr lang="en-US" dirty="0" smtClean="0">
+              <a:rPr lang="en-US" dirty="0">
                 <a:solidFill>
                   <a:srgbClr val="FF0000"/>
                 </a:solidFill>
@@ -4898,11 +4899,11 @@
               <a:t>independently</a:t>
             </a:r>
             <a:r>
-              <a:rPr lang="en-US" dirty="0" smtClean="0"/>
+              <a:rPr lang="en-US" dirty="0"/>
               <a:t>, or combined through refactoring, you often find that they </a:t>
             </a:r>
             <a:r>
-              <a:rPr lang="en-US" dirty="0" smtClean="0">
+              <a:rPr lang="en-US" dirty="0">
                 <a:solidFill>
                   <a:srgbClr val="FF0000"/>
                 </a:solidFill>
@@ -4910,18 +4911,18 @@
               <a:t>duplicate features</a:t>
             </a:r>
             <a:r>
-              <a:rPr lang="en-US" dirty="0" smtClean="0"/>
+              <a:rPr lang="en-US" dirty="0"/>
               <a:t>. </a:t>
             </a:r>
           </a:p>
           <a:p>
             <a:pPr algn="just"/>
-            <a:endParaRPr lang="en-US" dirty="0" smtClean="0"/>
+            <a:endParaRPr lang="en-US" dirty="0"/>
           </a:p>
           <a:p>
             <a:pPr algn="just"/>
             <a:r>
-              <a:rPr lang="en-US" b="1" dirty="0" smtClean="0">
+              <a:rPr lang="en-US" b="1" dirty="0">
                 <a:solidFill>
                   <a:srgbClr val="FF0000"/>
                 </a:solidFill>
@@ -4929,11 +4930,11 @@
               <a:t>***</a:t>
             </a:r>
             <a:r>
-              <a:rPr lang="en-US" dirty="0" smtClean="0"/>
+              <a:rPr lang="en-US" dirty="0"/>
               <a:t> In particular, certain </a:t>
             </a:r>
             <a:r>
-              <a:rPr lang="en-US" dirty="0" smtClean="0">
+              <a:rPr lang="en-US" dirty="0">
                 <a:solidFill>
                   <a:srgbClr val="FF0000"/>
                 </a:solidFill>
@@ -4941,11 +4942,11 @@
               <a:t>fields</a:t>
             </a:r>
             <a:r>
-              <a:rPr lang="en-US" dirty="0" smtClean="0"/>
+              <a:rPr lang="en-US" dirty="0"/>
               <a:t> can be </a:t>
             </a:r>
             <a:r>
-              <a:rPr lang="en-US" dirty="0" smtClean="0">
+              <a:rPr lang="en-US" dirty="0">
                 <a:solidFill>
                   <a:srgbClr val="FF0000"/>
                 </a:solidFill>
@@ -4953,11 +4954,11 @@
               <a:t>duplicates</a:t>
             </a:r>
             <a:r>
-              <a:rPr lang="en-US" dirty="0" smtClean="0"/>
+              <a:rPr lang="en-US" dirty="0"/>
               <a:t>. Such fields sometimes have </a:t>
             </a:r>
             <a:r>
-              <a:rPr lang="en-US" b="1" u="sng" dirty="0" smtClean="0">
+              <a:rPr lang="en-US" b="1" u="sng" dirty="0">
                 <a:solidFill>
                   <a:srgbClr val="FF0000"/>
                 </a:solidFill>
@@ -4965,15 +4966,15 @@
               <a:t>similar names </a:t>
             </a:r>
             <a:r>
-              <a:rPr lang="en-US" b="1" u="sng" dirty="0" smtClean="0"/>
+              <a:rPr lang="en-US" b="1" u="sng" dirty="0"/>
               <a:t>but not always</a:t>
             </a:r>
             <a:r>
-              <a:rPr lang="en-US" dirty="0" smtClean="0"/>
+              <a:rPr lang="en-US" dirty="0"/>
               <a:t>. The </a:t>
             </a:r>
             <a:r>
-              <a:rPr lang="en-US" b="1" dirty="0" smtClean="0">
+              <a:rPr lang="en-US" b="1" dirty="0">
                 <a:solidFill>
                   <a:srgbClr val="FF0000"/>
                 </a:solidFill>
@@ -4981,11 +4982,11 @@
               <a:t>only way </a:t>
             </a:r>
             <a:r>
-              <a:rPr lang="en-US" dirty="0" smtClean="0"/>
+              <a:rPr lang="en-US" dirty="0"/>
               <a:t>to determine what is going on is to </a:t>
             </a:r>
             <a:r>
-              <a:rPr lang="en-US" dirty="0" smtClean="0">
+              <a:rPr lang="en-US" dirty="0">
                 <a:solidFill>
                   <a:srgbClr val="FF0000"/>
                 </a:solidFill>
@@ -4993,11 +4994,11 @@
               <a:t>look at the fields </a:t>
             </a:r>
             <a:r>
-              <a:rPr lang="en-US" dirty="0" smtClean="0"/>
+              <a:rPr lang="en-US" dirty="0"/>
               <a:t>and see how they are </a:t>
             </a:r>
             <a:r>
-              <a:rPr lang="en-US" dirty="0" smtClean="0">
+              <a:rPr lang="en-US" dirty="0">
                 <a:solidFill>
                   <a:srgbClr val="FF0000"/>
                 </a:solidFill>
@@ -5005,38 +5006,38 @@
               <a:t>used by other methods</a:t>
             </a:r>
             <a:r>
-              <a:rPr lang="en-US" dirty="0" smtClean="0"/>
+              <a:rPr lang="en-US" dirty="0"/>
               <a:t>. If they are being used in a similar way, you can </a:t>
             </a:r>
             <a:r>
-              <a:rPr lang="fr-FR" dirty="0" err="1" smtClean="0"/>
+              <a:rPr lang="fr-FR" dirty="0" err="1"/>
               <a:t>generalize</a:t>
             </a:r>
             <a:r>
-              <a:rPr lang="fr-FR" dirty="0" smtClean="0"/>
+              <a:rPr lang="fr-FR" dirty="0"/>
               <a:t> </a:t>
             </a:r>
             <a:r>
-              <a:rPr lang="fr-FR" dirty="0" err="1" smtClean="0"/>
+              <a:rPr lang="fr-FR" dirty="0" err="1"/>
               <a:t>them</a:t>
             </a:r>
             <a:r>
-              <a:rPr lang="fr-FR" dirty="0" smtClean="0"/>
+              <a:rPr lang="fr-FR" dirty="0"/>
               <a:t>.</a:t>
             </a:r>
           </a:p>
           <a:p>
             <a:pPr algn="just"/>
-            <a:endParaRPr lang="en-US" dirty="0" smtClean="0"/>
+            <a:endParaRPr lang="en-US" dirty="0"/>
           </a:p>
           <a:p>
             <a:pPr algn="just"/>
             <a:r>
-              <a:rPr lang="en-US" dirty="0" smtClean="0"/>
+              <a:rPr lang="en-US" dirty="0"/>
               <a:t>Doing this </a:t>
             </a:r>
             <a:r>
-              <a:rPr lang="en-US" b="1" u="sng" dirty="0" smtClean="0">
+              <a:rPr lang="en-US" b="1" u="sng" dirty="0">
                 <a:solidFill>
                   <a:srgbClr val="FF0000"/>
                 </a:solidFill>
@@ -5044,11 +5045,11 @@
               <a:t>reduces duplication </a:t>
             </a:r>
             <a:r>
-              <a:rPr lang="en-US" b="1" u="sng" dirty="0" smtClean="0"/>
+              <a:rPr lang="en-US" b="1" u="sng" dirty="0"/>
               <a:t>in </a:t>
             </a:r>
             <a:r>
-              <a:rPr lang="en-US" b="1" u="sng" dirty="0" smtClean="0">
+              <a:rPr lang="en-US" b="1" u="sng" dirty="0">
                 <a:solidFill>
                   <a:srgbClr val="FF0000"/>
                 </a:solidFill>
@@ -5056,11 +5057,11 @@
               <a:t>two ways</a:t>
             </a:r>
             <a:r>
-              <a:rPr lang="en-US" dirty="0" smtClean="0"/>
+              <a:rPr lang="en-US" dirty="0"/>
               <a:t>. It removes the </a:t>
             </a:r>
             <a:r>
-              <a:rPr lang="en-US" b="1" u="sng" dirty="0" smtClean="0">
+              <a:rPr lang="en-US" b="1" u="sng" dirty="0">
                 <a:solidFill>
                   <a:srgbClr val="FF0000"/>
                 </a:solidFill>
@@ -5068,7 +5069,7 @@
               <a:t>duplicate data</a:t>
             </a:r>
             <a:r>
-              <a:rPr lang="en-US" dirty="0" smtClean="0">
+              <a:rPr lang="en-US" dirty="0">
                 <a:solidFill>
                   <a:srgbClr val="FF0000"/>
                 </a:solidFill>
@@ -5076,11 +5077,11 @@
               <a:t> </a:t>
             </a:r>
             <a:r>
-              <a:rPr lang="en-US" dirty="0" smtClean="0"/>
+              <a:rPr lang="en-US" dirty="0"/>
               <a:t>declaration and allows you to </a:t>
             </a:r>
             <a:r>
-              <a:rPr lang="en-US" dirty="0" smtClean="0">
+              <a:rPr lang="en-US" dirty="0">
                 <a:solidFill>
                   <a:srgbClr val="FF0000"/>
                 </a:solidFill>
@@ -5088,19 +5089,19 @@
               <a:t>move</a:t>
             </a:r>
             <a:r>
-              <a:rPr lang="en-US" dirty="0" smtClean="0"/>
+              <a:rPr lang="en-US" dirty="0"/>
               <a:t> from the subclasses to the </a:t>
             </a:r>
             <a:r>
-              <a:rPr lang="en-US" dirty="0" err="1" smtClean="0"/>
+              <a:rPr lang="en-US" dirty="0" err="1"/>
               <a:t>superclass</a:t>
             </a:r>
             <a:r>
-              <a:rPr lang="en-US" dirty="0" smtClean="0"/>
+              <a:rPr lang="en-US" dirty="0"/>
               <a:t> </a:t>
             </a:r>
             <a:r>
-              <a:rPr lang="en-US" b="1" u="sng" dirty="0" smtClean="0">
+              <a:rPr lang="en-US" b="1" u="sng" dirty="0">
                 <a:solidFill>
                   <a:srgbClr val="FF0000"/>
                 </a:solidFill>
@@ -5108,11 +5109,11 @@
               <a:t>methods</a:t>
             </a:r>
             <a:r>
-              <a:rPr lang="en-US" b="1" u="sng" dirty="0" smtClean="0"/>
+              <a:rPr lang="en-US" b="1" u="sng" dirty="0"/>
               <a:t> or </a:t>
             </a:r>
             <a:r>
-              <a:rPr lang="en-US" b="1" u="sng" dirty="0" smtClean="0">
+              <a:rPr lang="en-US" b="1" u="sng" dirty="0">
                 <a:solidFill>
                   <a:srgbClr val="FF0000"/>
                 </a:solidFill>
@@ -5120,11 +5121,11 @@
               <a:t>parts</a:t>
             </a:r>
             <a:r>
-              <a:rPr lang="en-US" b="1" u="sng" dirty="0" smtClean="0"/>
+              <a:rPr lang="en-US" b="1" u="sng" dirty="0"/>
               <a:t> of them that </a:t>
             </a:r>
             <a:r>
-              <a:rPr lang="en-US" b="1" u="sng" dirty="0" smtClean="0">
+              <a:rPr lang="en-US" b="1" u="sng" dirty="0">
                 <a:solidFill>
                   <a:srgbClr val="FF0000"/>
                 </a:solidFill>
@@ -5132,18 +5133,18 @@
               <a:t>use the field</a:t>
             </a:r>
             <a:r>
-              <a:rPr lang="en-US" dirty="0" smtClean="0"/>
+              <a:rPr lang="en-US" dirty="0"/>
               <a:t>.</a:t>
             </a:r>
           </a:p>
           <a:p>
             <a:pPr algn="just"/>
-            <a:endParaRPr lang="en-US" dirty="0" smtClean="0"/>
+            <a:endParaRPr lang="en-US" dirty="0"/>
           </a:p>
           <a:p>
             <a:pPr algn="just"/>
             <a:r>
-              <a:rPr lang="en-US" i="1" dirty="0" smtClean="0">
+              <a:rPr lang="en-US" i="1" dirty="0">
                 <a:solidFill>
                   <a:srgbClr val="0070C0"/>
                 </a:solidFill>
@@ -5151,7 +5152,7 @@
               <a:t>If the fields are </a:t>
             </a:r>
             <a:r>
-              <a:rPr lang="en-US" b="1" i="1" u="sng" dirty="0" smtClean="0">
+              <a:rPr lang="en-US" b="1" i="1" u="sng" dirty="0">
                 <a:solidFill>
                   <a:srgbClr val="0070C0"/>
                 </a:solidFill>
@@ -5159,7 +5160,7 @@
               <a:t>private</a:t>
             </a:r>
             <a:r>
-              <a:rPr lang="en-US" i="1" dirty="0" smtClean="0">
+              <a:rPr lang="en-US" i="1" dirty="0">
                 <a:solidFill>
                   <a:srgbClr val="0070C0"/>
                 </a:solidFill>
@@ -5167,7 +5168,7 @@
               <a:t>, you will need to </a:t>
             </a:r>
             <a:r>
-              <a:rPr lang="en-US" b="1" i="1" u="sng" dirty="0" smtClean="0">
+              <a:rPr lang="en-US" b="1" i="1" u="sng" dirty="0">
                 <a:solidFill>
                   <a:srgbClr val="0070C0"/>
                 </a:solidFill>
@@ -5175,7 +5176,7 @@
               <a:t>protect the </a:t>
             </a:r>
             <a:r>
-              <a:rPr lang="en-US" b="1" i="1" u="sng" dirty="0" err="1" smtClean="0">
+              <a:rPr lang="en-US" b="1" i="1" u="sng" dirty="0" err="1">
                 <a:solidFill>
                   <a:srgbClr val="0070C0"/>
                 </a:solidFill>
@@ -5183,7 +5184,7 @@
               <a:t>superclass</a:t>
             </a:r>
             <a:r>
-              <a:rPr lang="en-US" b="1" i="1" u="sng" dirty="0" smtClean="0">
+              <a:rPr lang="en-US" b="1" i="1" u="sng" dirty="0">
                 <a:solidFill>
                   <a:srgbClr val="0070C0"/>
                 </a:solidFill>
@@ -5191,14 +5192,14 @@
               <a:t> </a:t>
             </a:r>
             <a:r>
-              <a:rPr lang="en-US" i="1" dirty="0" smtClean="0">
+              <a:rPr lang="en-US" i="1" dirty="0">
                 <a:solidFill>
                   <a:srgbClr val="0070C0"/>
                 </a:solidFill>
               </a:rPr>
               <a:t>field so that the subclasses can refer to it.</a:t>
             </a:r>
-            <a:endParaRPr lang="en-US" dirty="0" smtClean="0">
+            <a:endParaRPr lang="en-US" dirty="0">
               <a:solidFill>
                 <a:srgbClr val="0070C0"/>
               </a:solidFill>
@@ -5206,7 +5207,7 @@
           </a:p>
           <a:p>
             <a:pPr algn="just"/>
-            <a:endParaRPr lang="en-US" dirty="0" smtClean="0"/>
+            <a:endParaRPr lang="en-US" dirty="0"/>
           </a:p>
           <a:p>
             <a:pPr algn="just"/>
@@ -5219,13 +5220,6 @@
   <p:clrMapOvr>
     <a:masterClrMapping/>
   </p:clrMapOvr>
-  <p:timing>
-    <p:tnLst>
-      <p:par>
-        <p:cTn id="1" dur="indefinite" restart="never" nodeType="tmRoot"/>
-      </p:par>
-    </p:tnLst>
-  </p:timing>
 </p:sld>
 </file>
 
@@ -5262,10 +5256,10 @@
           <a:lstStyle/>
           <a:p>
             <a:r>
-              <a:rPr lang="en-US" smtClean="0"/>
+              <a:rPr lang="en-US"/>
               <a:t>Pull Up Method</a:t>
             </a:r>
-            <a:endParaRPr lang="el-GR" smtClean="0"/>
+            <a:endParaRPr lang="el-GR"/>
           </a:p>
         </p:txBody>
       </p:sp>
@@ -5307,13 +5301,6 @@
   <p:clrMapOvr>
     <a:masterClrMapping/>
   </p:clrMapOvr>
-  <p:timing>
-    <p:tnLst>
-      <p:par>
-        <p:cTn id="1" dur="indefinite" restart="never" nodeType="tmRoot"/>
-      </p:par>
-    </p:tnLst>
-  </p:timing>
 </p:sld>
 </file>
 
@@ -5350,10 +5337,10 @@
           <a:lstStyle/>
           <a:p>
             <a:r>
-              <a:rPr lang="en-US" dirty="0" smtClean="0"/>
+              <a:rPr lang="en-US" dirty="0"/>
               <a:t>Pull Up Method</a:t>
             </a:r>
-            <a:endParaRPr lang="el-GR" dirty="0" smtClean="0"/>
+            <a:endParaRPr lang="el-GR" dirty="0"/>
           </a:p>
         </p:txBody>
       </p:sp>
@@ -5380,7 +5367,7 @@
           <a:p>
             <a:pPr algn="just"/>
             <a:r>
-              <a:rPr lang="en-US" dirty="0" smtClean="0">
+              <a:rPr lang="en-US" dirty="0">
                 <a:solidFill>
                   <a:srgbClr val="FF0000"/>
                 </a:solidFill>
@@ -5388,11 +5375,11 @@
               <a:t>Eliminating duplicate behavior </a:t>
             </a:r>
             <a:r>
-              <a:rPr lang="en-US" dirty="0" smtClean="0"/>
+              <a:rPr lang="en-US" dirty="0"/>
               <a:t>is important. Whenever there is duplication, you face the risk that an </a:t>
             </a:r>
             <a:r>
-              <a:rPr lang="en-US" dirty="0" smtClean="0">
+              <a:rPr lang="en-US" dirty="0">
                 <a:solidFill>
                   <a:srgbClr val="FF0000"/>
                 </a:solidFill>
@@ -5400,30 +5387,30 @@
               <a:t>alteration</a:t>
             </a:r>
             <a:r>
-              <a:rPr lang="en-US" dirty="0" smtClean="0"/>
+              <a:rPr lang="en-US" dirty="0"/>
               <a:t> to one will not be made to the other. </a:t>
             </a:r>
           </a:p>
           <a:p>
             <a:pPr algn="just"/>
-            <a:endParaRPr lang="en-US" dirty="0" smtClean="0"/>
+            <a:endParaRPr lang="en-US" dirty="0"/>
           </a:p>
           <a:p>
             <a:pPr algn="just"/>
             <a:r>
-              <a:rPr lang="en-US" dirty="0" smtClean="0"/>
+              <a:rPr lang="en-US" dirty="0"/>
               <a:t>The easiest case of using </a:t>
             </a:r>
             <a:r>
-              <a:rPr lang="en-US" i="1" dirty="0" smtClean="0"/>
+              <a:rPr lang="en-US" i="1" dirty="0"/>
               <a:t>Pull Up Method occurs when </a:t>
             </a:r>
             <a:r>
-              <a:rPr lang="en-US" b="1" i="1" dirty="0" smtClean="0"/>
+              <a:rPr lang="en-US" b="1" i="1" dirty="0"/>
               <a:t>the methods have </a:t>
             </a:r>
             <a:r>
-              <a:rPr lang="en-US" b="1" i="1" u="sng" dirty="0" smtClean="0">
+              <a:rPr lang="en-US" b="1" i="1" u="sng" dirty="0">
                 <a:solidFill>
                   <a:srgbClr val="FF0000"/>
                 </a:solidFill>
@@ -5431,15 +5418,15 @@
               <a:t>the same body</a:t>
             </a:r>
             <a:r>
-              <a:rPr lang="en-US" i="1" dirty="0" smtClean="0"/>
+              <a:rPr lang="en-US" i="1" dirty="0"/>
               <a:t>, </a:t>
             </a:r>
             <a:r>
-              <a:rPr lang="en-US" dirty="0" smtClean="0"/>
+              <a:rPr lang="en-US" dirty="0"/>
               <a:t>implying there's been a </a:t>
             </a:r>
             <a:r>
-              <a:rPr lang="en-US" dirty="0" smtClean="0">
+              <a:rPr lang="en-US" dirty="0">
                 <a:solidFill>
                   <a:srgbClr val="FF0000"/>
                 </a:solidFill>
@@ -5447,11 +5434,11 @@
               <a:t>copy and paste</a:t>
             </a:r>
             <a:r>
-              <a:rPr lang="en-US" dirty="0" smtClean="0"/>
+              <a:rPr lang="en-US" dirty="0"/>
               <a:t>. You may need to </a:t>
             </a:r>
             <a:r>
-              <a:rPr lang="en-US" dirty="0" smtClean="0">
+              <a:rPr lang="en-US" dirty="0">
                 <a:solidFill>
                   <a:srgbClr val="FF0000"/>
                 </a:solidFill>
@@ -5459,26 +5446,26 @@
               <a:t>change</a:t>
             </a:r>
             <a:r>
-              <a:rPr lang="en-US" dirty="0" smtClean="0"/>
+              <a:rPr lang="en-US" dirty="0"/>
               <a:t> a method's signature to get this to work.</a:t>
             </a:r>
           </a:p>
           <a:p>
             <a:pPr algn="just"/>
-            <a:endParaRPr lang="en-US" dirty="0" smtClean="0"/>
+            <a:endParaRPr lang="en-US" dirty="0"/>
           </a:p>
           <a:p>
             <a:pPr algn="just"/>
             <a:r>
-              <a:rPr lang="en-US" dirty="0" smtClean="0"/>
+              <a:rPr lang="en-US" dirty="0"/>
               <a:t>Of course it's not always as obvious as that.  Often </a:t>
             </a:r>
             <a:r>
-              <a:rPr lang="en-US" i="1" dirty="0" smtClean="0"/>
+              <a:rPr lang="en-US" i="1" dirty="0"/>
               <a:t>Pull Up Method comes after other steps. You see two methods in different classes that </a:t>
             </a:r>
             <a:r>
-              <a:rPr lang="en-US" b="1" i="1" u="sng" dirty="0" smtClean="0">
+              <a:rPr lang="en-US" b="1" i="1" u="sng" dirty="0">
                 <a:solidFill>
                   <a:srgbClr val="FF0000"/>
                 </a:solidFill>
@@ -5486,7 +5473,7 @@
               <a:t>can </a:t>
             </a:r>
             <a:r>
-              <a:rPr lang="en-US" b="1" u="sng" dirty="0" smtClean="0">
+              <a:rPr lang="en-US" b="1" u="sng" dirty="0">
                 <a:solidFill>
                   <a:srgbClr val="FF0000"/>
                 </a:solidFill>
@@ -5494,15 +5481,15 @@
               <a:t>be parameterized </a:t>
             </a:r>
             <a:r>
-              <a:rPr lang="en-US" dirty="0" smtClean="0"/>
+              <a:rPr lang="en-US" dirty="0"/>
               <a:t>in such a way that they </a:t>
             </a:r>
             <a:r>
-              <a:rPr lang="en-US" b="1" u="sng" dirty="0" smtClean="0"/>
+              <a:rPr lang="en-US" b="1" u="sng" dirty="0"/>
               <a:t>end up as essentially the </a:t>
             </a:r>
             <a:r>
-              <a:rPr lang="en-US" b="1" u="sng" dirty="0" smtClean="0">
+              <a:rPr lang="en-US" b="1" u="sng" dirty="0">
                 <a:solidFill>
                   <a:srgbClr val="FF0000"/>
                 </a:solidFill>
@@ -5510,21 +5497,21 @@
               <a:t>same method</a:t>
             </a:r>
             <a:r>
-              <a:rPr lang="en-US" dirty="0" smtClean="0"/>
+              <a:rPr lang="en-US" dirty="0"/>
               <a:t>. In that case the smallest step is to parameterize each method separately and then generalize them. </a:t>
             </a:r>
           </a:p>
           <a:p>
             <a:pPr algn="just"/>
-            <a:endParaRPr lang="en-US" dirty="0" smtClean="0"/>
+            <a:endParaRPr lang="en-US" dirty="0"/>
           </a:p>
           <a:p>
             <a:pPr algn="just"/>
-            <a:endParaRPr lang="en-US" dirty="0" smtClean="0"/>
+            <a:endParaRPr lang="en-US" dirty="0"/>
           </a:p>
           <a:p>
             <a:pPr algn="just"/>
-            <a:endParaRPr lang="en-US" dirty="0" smtClean="0"/>
+            <a:endParaRPr lang="en-US" dirty="0"/>
           </a:p>
         </p:txBody>
       </p:sp>
@@ -5533,13 +5520,6 @@
   <p:clrMapOvr>
     <a:masterClrMapping/>
   </p:clrMapOvr>
-  <p:timing>
-    <p:tnLst>
-      <p:par>
-        <p:cTn id="1" dur="indefinite" restart="never" nodeType="tmRoot"/>
-      </p:par>
-    </p:tnLst>
-  </p:timing>
 </p:sld>
 </file>
 
@@ -5576,10 +5556,10 @@
           <a:lstStyle/>
           <a:p>
             <a:r>
-              <a:rPr lang="en-US" dirty="0" smtClean="0"/>
+              <a:rPr lang="en-US" dirty="0"/>
               <a:t>Duplication</a:t>
             </a:r>
-            <a:endParaRPr lang="el-GR" dirty="0" smtClean="0"/>
+            <a:endParaRPr lang="el-GR" dirty="0"/>
           </a:p>
         </p:txBody>
       </p:sp>
@@ -5606,7 +5586,7 @@
           <a:p>
             <a:pPr algn="just"/>
             <a:r>
-              <a:rPr lang="en-US" b="1" u="sng" dirty="0" smtClean="0">
+              <a:rPr lang="en-US" b="1" u="sng" dirty="0">
                 <a:solidFill>
                   <a:srgbClr val="0070C0"/>
                 </a:solidFill>
@@ -5616,12 +5596,12 @@
           </a:p>
           <a:p>
             <a:pPr algn="just"/>
-            <a:endParaRPr lang="en-US" dirty="0" smtClean="0"/>
+            <a:endParaRPr lang="en-US" dirty="0"/>
           </a:p>
           <a:p>
             <a:pPr algn="just"/>
             <a:r>
-              <a:rPr lang="en-US" b="1" dirty="0" smtClean="0">
+              <a:rPr lang="en-US" b="1" dirty="0">
                 <a:solidFill>
                   <a:srgbClr val="FF0000"/>
                 </a:solidFill>
@@ -5629,15 +5609,15 @@
               <a:t>***</a:t>
             </a:r>
             <a:r>
-              <a:rPr lang="en-US" dirty="0" smtClean="0"/>
+              <a:rPr lang="en-US" dirty="0"/>
               <a:t> The most awkward element of </a:t>
             </a:r>
             <a:r>
-              <a:rPr lang="en-US" i="1" dirty="0" smtClean="0"/>
+              <a:rPr lang="en-US" i="1" dirty="0"/>
               <a:t>Pull Up Method is that the </a:t>
             </a:r>
             <a:r>
-              <a:rPr lang="en-US" i="1" dirty="0" smtClean="0">
+              <a:rPr lang="en-US" i="1" dirty="0">
                 <a:solidFill>
                   <a:srgbClr val="FF0000"/>
                 </a:solidFill>
@@ -5645,11 +5625,11 @@
               <a:t>body of the methods </a:t>
             </a:r>
             <a:r>
-              <a:rPr lang="en-US" i="1" dirty="0" smtClean="0"/>
+              <a:rPr lang="en-US" i="1" dirty="0"/>
               <a:t>may </a:t>
             </a:r>
             <a:r>
-              <a:rPr lang="en-US" b="1" i="1" u="sng" dirty="0" smtClean="0">
+              <a:rPr lang="en-US" b="1" i="1" u="sng" dirty="0">
                 <a:solidFill>
                   <a:srgbClr val="FF0000"/>
                 </a:solidFill>
@@ -5657,11 +5637,11 @@
               <a:t>refer</a:t>
             </a:r>
             <a:r>
-              <a:rPr lang="en-US" b="1" i="1" u="sng" dirty="0" smtClean="0"/>
+              <a:rPr lang="en-US" b="1" i="1" u="sng" dirty="0"/>
               <a:t> to </a:t>
             </a:r>
             <a:r>
-              <a:rPr lang="en-US" b="1" u="sng" dirty="0" smtClean="0">
+              <a:rPr lang="en-US" b="1" u="sng" dirty="0">
                 <a:solidFill>
                   <a:srgbClr val="FF0000"/>
                 </a:solidFill>
@@ -5669,11 +5649,11 @@
               <a:t>features</a:t>
             </a:r>
             <a:r>
-              <a:rPr lang="en-US" b="1" u="sng" dirty="0" smtClean="0"/>
+              <a:rPr lang="en-US" b="1" u="sng" dirty="0"/>
               <a:t> that are on the </a:t>
             </a:r>
             <a:r>
-              <a:rPr lang="en-US" b="1" u="sng" dirty="0" smtClean="0">
+              <a:rPr lang="en-US" b="1" u="sng" dirty="0">
                 <a:solidFill>
                   <a:srgbClr val="FF0000"/>
                 </a:solidFill>
@@ -5681,19 +5661,19 @@
               <a:t>subclass</a:t>
             </a:r>
             <a:r>
-              <a:rPr lang="en-US" b="1" u="sng" dirty="0" smtClean="0"/>
+              <a:rPr lang="en-US" b="1" u="sng" dirty="0"/>
               <a:t> but not on the </a:t>
             </a:r>
             <a:r>
-              <a:rPr lang="en-US" b="1" u="sng" dirty="0" err="1" smtClean="0"/>
+              <a:rPr lang="en-US" b="1" u="sng" dirty="0" err="1"/>
               <a:t>superclass</a:t>
             </a:r>
             <a:r>
-              <a:rPr lang="en-US" dirty="0" smtClean="0"/>
+              <a:rPr lang="en-US" dirty="0"/>
               <a:t>. If the feature is a method, you can either </a:t>
             </a:r>
             <a:r>
-              <a:rPr lang="en-US" dirty="0" smtClean="0">
+              <a:rPr lang="en-US" dirty="0">
                 <a:solidFill>
                   <a:srgbClr val="FF0000"/>
                 </a:solidFill>
@@ -5701,11 +5681,11 @@
               <a:t>generalize the other method </a:t>
             </a:r>
             <a:r>
-              <a:rPr lang="en-US" dirty="0" smtClean="0"/>
+              <a:rPr lang="en-US" dirty="0"/>
               <a:t>or create an </a:t>
             </a:r>
             <a:r>
-              <a:rPr lang="en-US" dirty="0" smtClean="0">
+              <a:rPr lang="en-US" dirty="0">
                 <a:solidFill>
                   <a:srgbClr val="FF0000"/>
                 </a:solidFill>
@@ -5713,30 +5693,30 @@
               <a:t>abstract method </a:t>
             </a:r>
             <a:r>
-              <a:rPr lang="en-US" dirty="0" smtClean="0"/>
+              <a:rPr lang="en-US" dirty="0"/>
               <a:t>in the </a:t>
             </a:r>
             <a:r>
-              <a:rPr lang="en-US" dirty="0" err="1" smtClean="0"/>
+              <a:rPr lang="en-US" dirty="0" err="1"/>
               <a:t>superclass</a:t>
             </a:r>
             <a:r>
-              <a:rPr lang="en-US" dirty="0" smtClean="0"/>
+              <a:rPr lang="en-US" dirty="0"/>
               <a:t>.</a:t>
             </a:r>
           </a:p>
           <a:p>
             <a:pPr algn="just"/>
-            <a:endParaRPr lang="en-US" dirty="0" smtClean="0"/>
+            <a:endParaRPr lang="en-US" dirty="0"/>
           </a:p>
           <a:p>
             <a:pPr algn="just"/>
             <a:r>
-              <a:rPr lang="en-US" dirty="0" smtClean="0"/>
+              <a:rPr lang="en-US" dirty="0"/>
               <a:t>Then you may be able to use </a:t>
             </a:r>
             <a:r>
-              <a:rPr lang="en-US" b="1" i="1" dirty="0" smtClean="0">
+              <a:rPr lang="en-US" b="1" i="1" dirty="0">
                 <a:solidFill>
                   <a:srgbClr val="0070C0"/>
                 </a:solidFill>
@@ -5744,15 +5724,15 @@
               <a:t>Form Template Method</a:t>
             </a:r>
             <a:r>
-              <a:rPr lang="en-US" b="1" i="1" dirty="0" smtClean="0"/>
+              <a:rPr lang="en-US" b="1" i="1" dirty="0"/>
               <a:t> </a:t>
             </a:r>
             <a:r>
-              <a:rPr lang="en-US" i="1" dirty="0" smtClean="0"/>
+              <a:rPr lang="en-US" i="1" dirty="0"/>
               <a:t>to create </a:t>
             </a:r>
             <a:r>
-              <a:rPr lang="en-US" i="1" dirty="0" smtClean="0">
+              <a:rPr lang="en-US" i="1" dirty="0">
                 <a:solidFill>
                   <a:srgbClr val="0070C0"/>
                 </a:solidFill>
@@ -5760,7 +5740,7 @@
               <a:t>a </a:t>
             </a:r>
             <a:r>
-              <a:rPr lang="en-US" dirty="0" smtClean="0">
+              <a:rPr lang="en-US" dirty="0">
                 <a:solidFill>
                   <a:srgbClr val="0070C0"/>
                 </a:solidFill>
@@ -5768,11 +5748,11 @@
               <a:t>common algorithm </a:t>
             </a:r>
             <a:r>
-              <a:rPr lang="en-US" dirty="0" smtClean="0"/>
+              <a:rPr lang="en-US" dirty="0"/>
               <a:t>in the </a:t>
             </a:r>
             <a:r>
-              <a:rPr lang="en-US" dirty="0" smtClean="0">
+              <a:rPr lang="en-US" dirty="0">
                 <a:solidFill>
                   <a:srgbClr val="0070C0"/>
                 </a:solidFill>
@@ -5780,11 +5760,11 @@
               <a:t>parent</a:t>
             </a:r>
             <a:r>
-              <a:rPr lang="en-US" dirty="0" smtClean="0"/>
+              <a:rPr lang="en-US" dirty="0"/>
               <a:t>, and </a:t>
             </a:r>
             <a:r>
-              <a:rPr lang="en-US" dirty="0" smtClean="0">
+              <a:rPr lang="en-US" dirty="0">
                 <a:solidFill>
                   <a:srgbClr val="0070C0"/>
                 </a:solidFill>
@@ -5792,11 +5772,11 @@
               <a:t>unique steps </a:t>
             </a:r>
             <a:r>
-              <a:rPr lang="en-US" dirty="0" smtClean="0"/>
+              <a:rPr lang="en-US" dirty="0"/>
               <a:t>in the </a:t>
             </a:r>
             <a:r>
-              <a:rPr lang="en-US" dirty="0" smtClean="0">
+              <a:rPr lang="en-US" dirty="0">
                 <a:solidFill>
                   <a:srgbClr val="0070C0"/>
                 </a:solidFill>
@@ -5804,7 +5784,7 @@
               <a:t>children</a:t>
             </a:r>
             <a:r>
-              <a:rPr lang="en-US" dirty="0" smtClean="0"/>
+              <a:rPr lang="en-US" dirty="0"/>
               <a:t>.</a:t>
             </a:r>
           </a:p>
@@ -5815,13 +5795,6 @@
   <p:clrMapOvr>
     <a:masterClrMapping/>
   </p:clrMapOvr>
-  <p:timing>
-    <p:tnLst>
-      <p:par>
-        <p:cTn id="1" dur="indefinite" restart="never" nodeType="tmRoot"/>
-      </p:par>
-    </p:tnLst>
-  </p:timing>
 </p:sld>
 </file>
 
@@ -5916,7 +5889,7 @@
               <a:defRPr/>
             </a:pPr>
             <a:r>
-              <a:rPr kumimoji="0" lang="en-US" sz="3200" b="0" i="0" u="none" strike="noStrike" kern="1200" cap="none" spc="0" normalizeH="0" baseline="0" noProof="0" smtClean="0">
+              <a:rPr kumimoji="0" lang="en-US" sz="3200" b="0" i="0" u="none" strike="noStrike" kern="1200" cap="none" spc="0" normalizeH="0" baseline="0" noProof="0">
                 <a:ln>
                   <a:noFill/>
                 </a:ln>
@@ -5932,7 +5905,7 @@
               </a:rPr>
               <a:t>Form Template Method</a:t>
             </a:r>
-            <a:endParaRPr kumimoji="0" lang="el-GR" sz="3200" b="0" i="0" u="none" strike="noStrike" kern="1200" cap="none" spc="0" normalizeH="0" baseline="0" noProof="0" dirty="0" smtClean="0">
+            <a:endParaRPr kumimoji="0" lang="el-GR" sz="3200" b="0" i="0" u="none" strike="noStrike" kern="1200" cap="none" spc="0" normalizeH="0" baseline="0" noProof="0" dirty="0">
               <a:ln>
                 <a:noFill/>
               </a:ln>
@@ -5954,13 +5927,6 @@
   <p:clrMapOvr>
     <a:masterClrMapping/>
   </p:clrMapOvr>
-  <p:timing>
-    <p:tnLst>
-      <p:par>
-        <p:cTn id="1" dur="indefinite" restart="never" nodeType="tmRoot"/>
-      </p:par>
-    </p:tnLst>
-  </p:timing>
 </p:sld>
 </file>
 
@@ -5997,10 +5963,10 @@
           <a:lstStyle/>
           <a:p>
             <a:r>
-              <a:rPr lang="en-US" dirty="0" smtClean="0"/>
+              <a:rPr lang="en-US" dirty="0"/>
               <a:t>Form Template Method</a:t>
             </a:r>
-            <a:endParaRPr lang="el-GR" dirty="0" smtClean="0"/>
+            <a:endParaRPr lang="el-GR" dirty="0"/>
           </a:p>
         </p:txBody>
       </p:sp>
@@ -6027,30 +5993,30 @@
           <a:p>
             <a:pPr algn="just"/>
             <a:r>
-              <a:rPr lang="en-US" dirty="0" smtClean="0"/>
+              <a:rPr lang="en-US" dirty="0"/>
               <a:t>Inheritance is a powerful tool for eliminating duplicate behavior. Whenever we see two similar methods in subclasses, we want to bring them together in a </a:t>
             </a:r>
             <a:r>
-              <a:rPr lang="en-US" dirty="0" err="1" smtClean="0"/>
+              <a:rPr lang="en-US" dirty="0" err="1"/>
               <a:t>superclass</a:t>
             </a:r>
             <a:r>
-              <a:rPr lang="en-US" dirty="0" smtClean="0"/>
+              <a:rPr lang="en-US" dirty="0"/>
               <a:t>. </a:t>
             </a:r>
           </a:p>
           <a:p>
             <a:pPr algn="just"/>
-            <a:endParaRPr lang="en-US" dirty="0" smtClean="0"/>
+            <a:endParaRPr lang="en-US" dirty="0"/>
           </a:p>
           <a:p>
             <a:pPr algn="just"/>
             <a:r>
-              <a:rPr lang="en-US" dirty="0" smtClean="0"/>
+              <a:rPr lang="en-US" dirty="0"/>
               <a:t>A common case is </a:t>
             </a:r>
             <a:r>
-              <a:rPr lang="en-US" b="1" u="sng" dirty="0" smtClean="0">
+              <a:rPr lang="en-US" b="1" u="sng" dirty="0">
                 <a:solidFill>
                   <a:srgbClr val="FF0000"/>
                 </a:solidFill>
@@ -6058,11 +6024,11 @@
               <a:t>two methods </a:t>
             </a:r>
             <a:r>
-              <a:rPr lang="en-US" b="1" u="sng" dirty="0" smtClean="0"/>
+              <a:rPr lang="en-US" b="1" u="sng" dirty="0"/>
               <a:t>that seem to carry out broadly </a:t>
             </a:r>
             <a:r>
-              <a:rPr lang="en-US" b="1" u="sng" dirty="0" smtClean="0">
+              <a:rPr lang="en-US" b="1" u="sng" dirty="0">
                 <a:solidFill>
                   <a:srgbClr val="FF0000"/>
                 </a:solidFill>
@@ -6070,11 +6036,11 @@
               <a:t>similar steps </a:t>
             </a:r>
             <a:r>
-              <a:rPr lang="en-US" b="1" u="sng" dirty="0" smtClean="0"/>
+              <a:rPr lang="en-US" b="1" u="sng" dirty="0"/>
               <a:t>in the same </a:t>
             </a:r>
             <a:r>
-              <a:rPr lang="en-US" b="1" u="sng" dirty="0" smtClean="0">
+              <a:rPr lang="en-US" b="1" u="sng" dirty="0">
                 <a:solidFill>
                   <a:srgbClr val="FF0000"/>
                 </a:solidFill>
@@ -6082,11 +6048,11 @@
               <a:t>sequence</a:t>
             </a:r>
             <a:r>
-              <a:rPr lang="en-US" b="1" u="sng" dirty="0" smtClean="0"/>
+              <a:rPr lang="en-US" b="1" u="sng" dirty="0"/>
               <a:t>, but the steps are </a:t>
             </a:r>
             <a:r>
-              <a:rPr lang="en-US" b="1" u="sng" dirty="0" smtClean="0">
+              <a:rPr lang="en-US" b="1" u="sng" dirty="0">
                 <a:solidFill>
                   <a:srgbClr val="FF0000"/>
                 </a:solidFill>
@@ -6094,15 +6060,15 @@
               <a:t>not the same</a:t>
             </a:r>
             <a:r>
-              <a:rPr lang="en-US" dirty="0" smtClean="0"/>
+              <a:rPr lang="en-US" dirty="0"/>
               <a:t>. In this case we can </a:t>
             </a:r>
             <a:r>
-              <a:rPr lang="en-US" b="1" u="sng" dirty="0" smtClean="0"/>
+              <a:rPr lang="en-US" b="1" u="sng" dirty="0"/>
               <a:t>move the </a:t>
             </a:r>
             <a:r>
-              <a:rPr lang="en-US" b="1" u="sng" dirty="0" smtClean="0">
+              <a:rPr lang="en-US" b="1" u="sng" dirty="0">
                 <a:solidFill>
                   <a:srgbClr val="FF0000"/>
                 </a:solidFill>
@@ -6110,7 +6076,7 @@
               <a:t>sequence to the </a:t>
             </a:r>
             <a:r>
-              <a:rPr lang="en-US" b="1" u="sng" dirty="0" err="1" smtClean="0">
+              <a:rPr lang="en-US" b="1" u="sng" dirty="0" err="1">
                 <a:solidFill>
                   <a:srgbClr val="FF0000"/>
                 </a:solidFill>
@@ -6118,7 +6084,7 @@
               <a:t>superclass</a:t>
             </a:r>
             <a:r>
-              <a:rPr lang="en-US" b="1" u="sng" dirty="0" smtClean="0">
+              <a:rPr lang="en-US" b="1" u="sng" dirty="0">
                 <a:solidFill>
                   <a:srgbClr val="FF0000"/>
                 </a:solidFill>
@@ -6126,15 +6092,15 @@
               <a:t> </a:t>
             </a:r>
             <a:r>
-              <a:rPr lang="en-US" b="1" u="sng" dirty="0" smtClean="0"/>
+              <a:rPr lang="en-US" b="1" u="sng" dirty="0"/>
               <a:t>and allow polymorphism to play its role in ensuring the different steps do their things differently</a:t>
             </a:r>
             <a:r>
-              <a:rPr lang="en-US" dirty="0" smtClean="0"/>
+              <a:rPr lang="en-US" dirty="0"/>
               <a:t>.  This kind of method is called a </a:t>
             </a:r>
             <a:r>
-              <a:rPr lang="en-US" i="1" dirty="0" smtClean="0">
+              <a:rPr lang="en-US" i="1" dirty="0">
                 <a:solidFill>
                   <a:srgbClr val="FF0000"/>
                 </a:solidFill>
@@ -6154,13 +6120,6 @@
   <p:clrMapOvr>
     <a:masterClrMapping/>
   </p:clrMapOvr>
-  <p:timing>
-    <p:tnLst>
-      <p:par>
-        <p:cTn id="1" dur="indefinite" restart="never" nodeType="tmRoot"/>
-      </p:par>
-    </p:tnLst>
-  </p:timing>
 </p:sld>
 </file>
 
@@ -6197,10 +6156,10 @@
           <a:lstStyle/>
           <a:p>
             <a:r>
-              <a:rPr lang="en-US" dirty="0" smtClean="0"/>
+              <a:rPr lang="en-US" dirty="0"/>
               <a:t>Duplication</a:t>
             </a:r>
-            <a:endParaRPr lang="el-GR" dirty="0" smtClean="0"/>
+            <a:endParaRPr lang="el-GR" dirty="0"/>
           </a:p>
         </p:txBody>
       </p:sp>
@@ -6227,7 +6186,7 @@
           <a:p>
             <a:pPr algn="just"/>
             <a:r>
-              <a:rPr lang="en-US" b="1" u="sng" dirty="0" smtClean="0">
+              <a:rPr lang="en-US" b="1" u="sng" dirty="0">
                 <a:solidFill>
                   <a:srgbClr val="0070C0"/>
                 </a:solidFill>
@@ -6237,16 +6196,16 @@
           </a:p>
           <a:p>
             <a:pPr algn="just"/>
-            <a:endParaRPr lang="en-US" dirty="0" smtClean="0"/>
+            <a:endParaRPr lang="en-US" dirty="0"/>
           </a:p>
           <a:p>
             <a:pPr algn="just"/>
             <a:r>
-              <a:rPr lang="en-US" dirty="0" smtClean="0"/>
+              <a:rPr lang="en-US" dirty="0"/>
               <a:t>If the duplication is in </a:t>
             </a:r>
             <a:r>
-              <a:rPr lang="en-US" b="1" dirty="0" smtClean="0">
+              <a:rPr lang="en-US" b="1" dirty="0">
                 <a:solidFill>
                   <a:srgbClr val="0070C0"/>
                 </a:solidFill>
@@ -6254,13 +6213,13 @@
               <a:t>two unrelated classes</a:t>
             </a:r>
             <a:r>
-              <a:rPr lang="en-US" dirty="0" smtClean="0"/>
+              <a:rPr lang="en-US" dirty="0"/>
               <a:t>: </a:t>
             </a:r>
           </a:p>
           <a:p>
             <a:pPr algn="just"/>
-            <a:endParaRPr lang="en-US" dirty="0" smtClean="0"/>
+            <a:endParaRPr lang="en-US" dirty="0"/>
           </a:p>
           <a:p>
             <a:pPr marL="800100" lvl="1" indent="-342900" algn="just">
@@ -6268,11 +6227,11 @@
               <a:buAutoNum type="arabicPeriod"/>
             </a:pPr>
             <a:r>
-              <a:rPr lang="en-US" dirty="0" smtClean="0"/>
+              <a:rPr lang="en-US" dirty="0"/>
               <a:t>either </a:t>
             </a:r>
             <a:r>
-              <a:rPr lang="en-US" b="1" dirty="0" smtClean="0">
+              <a:rPr lang="en-US" b="1" dirty="0">
                 <a:solidFill>
                   <a:srgbClr val="0070C0"/>
                 </a:solidFill>
@@ -6280,11 +6239,11 @@
               <a:t>extract the common part</a:t>
             </a:r>
             <a:r>
-              <a:rPr lang="en-US" dirty="0" smtClean="0"/>
+              <a:rPr lang="en-US" dirty="0"/>
               <a:t> into a new class via </a:t>
             </a:r>
             <a:r>
-              <a:rPr lang="en-US" b="1" i="1" dirty="0" smtClean="0">
+              <a:rPr lang="en-US" b="1" i="1" dirty="0">
                 <a:solidFill>
                   <a:srgbClr val="0070C0"/>
                 </a:solidFill>
@@ -6292,7 +6251,7 @@
               <a:t>Extract Class</a:t>
             </a:r>
             <a:r>
-              <a:rPr lang="en-US" i="1" dirty="0" smtClean="0"/>
+              <a:rPr lang="en-US" i="1" dirty="0"/>
               <a:t>, or </a:t>
             </a:r>
           </a:p>
@@ -6302,11 +6261,11 @@
               <a:buAutoNum type="arabicPeriod"/>
             </a:pPr>
             <a:r>
-              <a:rPr lang="en-US" i="1" dirty="0" smtClean="0"/>
+              <a:rPr lang="en-US" i="1" dirty="0"/>
               <a:t>Check if </a:t>
             </a:r>
             <a:r>
-              <a:rPr lang="en-US" b="1" i="1" dirty="0" smtClean="0">
+              <a:rPr lang="en-US" b="1" i="1" dirty="0">
                 <a:solidFill>
                   <a:srgbClr val="0070C0"/>
                 </a:solidFill>
@@ -6314,7 +6273,7 @@
               <a:t>the </a:t>
             </a:r>
             <a:r>
-              <a:rPr lang="en-US" b="1" dirty="0" smtClean="0">
+              <a:rPr lang="en-US" b="1" dirty="0">
                 <a:solidFill>
                   <a:srgbClr val="0070C0"/>
                 </a:solidFill>
@@ -6322,22 +6281,22 @@
               <a:t>common code really belongs on only one class or the other</a:t>
             </a:r>
             <a:r>
-              <a:rPr lang="en-US" dirty="0" smtClean="0"/>
+              <a:rPr lang="en-US" dirty="0"/>
               <a:t>.</a:t>
             </a:r>
           </a:p>
           <a:p>
             <a:pPr algn="just"/>
-            <a:endParaRPr lang="en-US" dirty="0" smtClean="0"/>
+            <a:endParaRPr lang="en-US" dirty="0"/>
           </a:p>
           <a:p>
             <a:pPr algn="just"/>
             <a:r>
-              <a:rPr lang="en-US" dirty="0" smtClean="0"/>
+              <a:rPr lang="en-US" dirty="0"/>
               <a:t>In any of these cases, you may find that the two places </a:t>
             </a:r>
             <a:r>
-              <a:rPr lang="en-US" dirty="0" smtClean="0">
+              <a:rPr lang="en-US" dirty="0">
                 <a:solidFill>
                   <a:srgbClr val="0070C0"/>
                 </a:solidFill>
@@ -6345,11 +6304,11 @@
               <a:t>aren’t literally identical </a:t>
             </a:r>
             <a:r>
-              <a:rPr lang="en-US" dirty="0" smtClean="0"/>
+              <a:rPr lang="en-US" dirty="0"/>
               <a:t>but have </a:t>
             </a:r>
             <a:r>
-              <a:rPr lang="en-US" dirty="0" smtClean="0">
+              <a:rPr lang="en-US" dirty="0">
                 <a:solidFill>
                   <a:srgbClr val="0070C0"/>
                 </a:solidFill>
@@ -6357,11 +6316,11 @@
               <a:t>the same effect</a:t>
             </a:r>
             <a:r>
-              <a:rPr lang="en-US" dirty="0" smtClean="0"/>
+              <a:rPr lang="en-US" dirty="0"/>
               <a:t>. Then you may do a </a:t>
             </a:r>
             <a:r>
-              <a:rPr lang="en-US" b="1" i="1" dirty="0" smtClean="0">
+              <a:rPr lang="en-US" b="1" i="1" dirty="0">
                 <a:solidFill>
                   <a:srgbClr val="0070C0"/>
                 </a:solidFill>
@@ -6369,22 +6328,22 @@
               <a:t>Substitute Algorithm </a:t>
             </a:r>
             <a:r>
-              <a:rPr lang="en-US" i="1" dirty="0" smtClean="0"/>
+              <a:rPr lang="en-US" i="1" dirty="0"/>
               <a:t>so that only one </a:t>
             </a:r>
             <a:r>
-              <a:rPr lang="en-US" dirty="0" smtClean="0"/>
+              <a:rPr lang="en-US" dirty="0"/>
               <a:t>copy is involved.</a:t>
             </a:r>
           </a:p>
           <a:p>
             <a:pPr algn="just"/>
-            <a:endParaRPr lang="en-US" b="1" dirty="0" smtClean="0"/>
+            <a:endParaRPr lang="en-US" b="1" dirty="0"/>
           </a:p>
           <a:p>
             <a:pPr algn="just"/>
             <a:r>
-              <a:rPr lang="en-US" b="1" u="sng" dirty="0" smtClean="0">
+              <a:rPr lang="en-US" b="1" u="sng" dirty="0">
                 <a:solidFill>
                   <a:srgbClr val="0070C0"/>
                 </a:solidFill>
@@ -6394,23 +6353,18 @@
           </a:p>
           <a:p>
             <a:pPr algn="just"/>
-            <a:endParaRPr lang="en-US" dirty="0" smtClean="0"/>
+            <a:endParaRPr lang="en-US" dirty="0"/>
           </a:p>
           <a:p>
             <a:pPr algn="just"/>
             <a:r>
-              <a:rPr lang="en-US" b="1" dirty="0" smtClean="0">
+              <a:rPr lang="en-US" b="1" dirty="0">
                 <a:solidFill>
                   <a:srgbClr val="FF0000"/>
                 </a:solidFill>
               </a:rPr>
               <a:t>Reduces duplication, lowers size. Can lead to better abstractions and more flexible code.</a:t>
             </a:r>
-            <a:endParaRPr lang="en-US" b="1" dirty="0">
-              <a:solidFill>
-                <a:srgbClr val="FF0000"/>
-              </a:solidFill>
-            </a:endParaRPr>
           </a:p>
         </p:txBody>
       </p:sp>
@@ -6419,13 +6373,6 @@
   <p:clrMapOvr>
     <a:masterClrMapping/>
   </p:clrMapOvr>
-  <p:timing>
-    <p:tnLst>
-      <p:par>
-        <p:cTn id="1" dur="indefinite" restart="never" nodeType="tmRoot"/>
-      </p:par>
-    </p:tnLst>
-  </p:timing>
 </p:sld>
 </file>
 
@@ -6462,10 +6409,10 @@
           <a:lstStyle/>
           <a:p>
             <a:r>
-              <a:rPr lang="en-US" dirty="0" smtClean="0"/>
+              <a:rPr lang="en-US" dirty="0"/>
               <a:t>Substitute Algorithm</a:t>
             </a:r>
-            <a:endParaRPr lang="el-GR" dirty="0" smtClean="0"/>
+            <a:endParaRPr lang="el-GR" dirty="0"/>
           </a:p>
         </p:txBody>
       </p:sp>
@@ -6507,13 +6454,6 @@
   <p:clrMapOvr>
     <a:masterClrMapping/>
   </p:clrMapOvr>
-  <p:timing>
-    <p:tnLst>
-      <p:par>
-        <p:cTn id="1" dur="indefinite" restart="never" nodeType="tmRoot"/>
-      </p:par>
-    </p:tnLst>
-  </p:timing>
 </p:sld>
 </file>
 
@@ -6550,10 +6490,9 @@
           <a:lstStyle/>
           <a:p>
             <a:r>
-              <a:rPr lang="en-US" dirty="0" smtClean="0"/>
+              <a:rPr lang="en-US" dirty="0"/>
               <a:t>Duplication</a:t>
             </a:r>
-            <a:endParaRPr lang="en-US" dirty="0"/>
           </a:p>
         </p:txBody>
       </p:sp>
@@ -6617,10 +6556,10 @@
           <a:lstStyle/>
           <a:p>
             <a:r>
-              <a:rPr lang="en-US" dirty="0" smtClean="0"/>
+              <a:rPr lang="en-US" dirty="0"/>
               <a:t>Duplication</a:t>
             </a:r>
-            <a:endParaRPr lang="el-GR" dirty="0" smtClean="0"/>
+            <a:endParaRPr lang="el-GR" dirty="0"/>
           </a:p>
         </p:txBody>
       </p:sp>
@@ -6647,7 +6586,7 @@
           <a:p>
             <a:pPr algn="just"/>
             <a:r>
-              <a:rPr lang="en-US" b="1" u="sng" dirty="0" smtClean="0">
+              <a:rPr lang="en-US" b="1" u="sng" dirty="0">
                 <a:solidFill>
                   <a:srgbClr val="0070C0"/>
                 </a:solidFill>
@@ -6657,7 +6596,7 @@
           </a:p>
           <a:p>
             <a:pPr algn="just"/>
-            <a:endParaRPr lang="en-US" b="1" u="sng" dirty="0" smtClean="0">
+            <a:endParaRPr lang="en-US" b="1" u="sng" dirty="0">
               <a:solidFill>
                 <a:srgbClr val="0070C0"/>
               </a:solidFill>
@@ -6666,15 +6605,15 @@
           <a:p>
             <a:pPr algn="just"/>
             <a:r>
-              <a:rPr lang="en-US" i="1" dirty="0" smtClean="0"/>
+              <a:rPr lang="en-US" i="1" dirty="0"/>
               <a:t>The easy version: </a:t>
             </a:r>
             <a:r>
-              <a:rPr lang="en-US" dirty="0" smtClean="0"/>
+              <a:rPr lang="en-US" dirty="0"/>
               <a:t>Two fragments of code look </a:t>
             </a:r>
             <a:r>
-              <a:rPr lang="en-US" dirty="0" smtClean="0">
+              <a:rPr lang="en-US" dirty="0">
                 <a:solidFill>
                   <a:srgbClr val="0070C0"/>
                 </a:solidFill>
@@ -6682,26 +6621,26 @@
               <a:t>nearly identical</a:t>
             </a:r>
             <a:r>
-              <a:rPr lang="en-US" dirty="0" smtClean="0"/>
+              <a:rPr lang="en-US" dirty="0"/>
               <a:t>.</a:t>
             </a:r>
           </a:p>
           <a:p>
             <a:pPr algn="just"/>
-            <a:endParaRPr lang="en-US" i="1" dirty="0" smtClean="0"/>
+            <a:endParaRPr lang="en-US" i="1" dirty="0"/>
           </a:p>
           <a:p>
             <a:pPr algn="just"/>
             <a:r>
-              <a:rPr lang="en-US" i="1" dirty="0" smtClean="0"/>
+              <a:rPr lang="en-US" i="1" dirty="0"/>
               <a:t>The hard version: </a:t>
             </a:r>
             <a:r>
-              <a:rPr lang="en-US" dirty="0" smtClean="0"/>
+              <a:rPr lang="en-US" dirty="0"/>
               <a:t>Two fragments of code have </a:t>
             </a:r>
             <a:r>
-              <a:rPr lang="en-US" dirty="0" smtClean="0">
+              <a:rPr lang="en-US" dirty="0">
                 <a:solidFill>
                   <a:srgbClr val="0070C0"/>
                 </a:solidFill>
@@ -6709,18 +6648,18 @@
               <a:t>nearly identical effects</a:t>
             </a:r>
             <a:r>
-              <a:rPr lang="en-US" dirty="0" smtClean="0"/>
+              <a:rPr lang="en-US" dirty="0"/>
               <a:t> (at any conceptual level).</a:t>
             </a:r>
           </a:p>
           <a:p>
             <a:pPr algn="just"/>
-            <a:endParaRPr lang="en-US" b="1" dirty="0" smtClean="0"/>
+            <a:endParaRPr lang="en-US" b="1" dirty="0"/>
           </a:p>
           <a:p>
             <a:pPr algn="just"/>
             <a:r>
-              <a:rPr lang="en-US" b="1" u="sng" dirty="0" smtClean="0">
+              <a:rPr lang="en-US" b="1" u="sng" dirty="0">
                 <a:solidFill>
                   <a:srgbClr val="0070C0"/>
                 </a:solidFill>
@@ -6730,7 +6669,7 @@
           </a:p>
           <a:p>
             <a:pPr algn="just"/>
-            <a:endParaRPr lang="en-US" b="1" u="sng" dirty="0" smtClean="0">
+            <a:endParaRPr lang="en-US" b="1" u="sng" dirty="0">
               <a:solidFill>
                 <a:srgbClr val="0070C0"/>
               </a:solidFill>
@@ -6739,11 +6678,11 @@
           <a:p>
             <a:pPr algn="just"/>
             <a:r>
-              <a:rPr lang="en-US" dirty="0" smtClean="0"/>
+              <a:rPr lang="en-US" dirty="0"/>
               <a:t>Some duplication occurs because </a:t>
             </a:r>
             <a:r>
-              <a:rPr lang="en-US" dirty="0" smtClean="0">
+              <a:rPr lang="en-US" dirty="0">
                 <a:solidFill>
                   <a:srgbClr val="FF0000"/>
                 </a:solidFill>
@@ -6751,22 +6690,22 @@
               <a:t>programmers were working independently </a:t>
             </a:r>
             <a:r>
-              <a:rPr lang="en-US" dirty="0" smtClean="0"/>
+              <a:rPr lang="en-US" dirty="0"/>
               <a:t>in different parts of the system, and they didn’t realize that they were creating almost identical code.</a:t>
             </a:r>
           </a:p>
           <a:p>
             <a:pPr algn="just"/>
-            <a:endParaRPr lang="en-US" dirty="0" smtClean="0"/>
+            <a:endParaRPr lang="en-US" dirty="0"/>
           </a:p>
           <a:p>
             <a:pPr algn="just"/>
             <a:r>
-              <a:rPr lang="en-US" dirty="0" smtClean="0"/>
+              <a:rPr lang="en-US" dirty="0"/>
               <a:t>A </a:t>
             </a:r>
             <a:r>
-              <a:rPr lang="en-US" b="1" dirty="0" smtClean="0">
+              <a:rPr lang="en-US" b="1" dirty="0">
                 <a:solidFill>
                   <a:srgbClr val="FF0000"/>
                 </a:solidFill>
@@ -6774,11 +6713,11 @@
               <a:t>worse case (but perhaps the most common)</a:t>
             </a:r>
             <a:r>
-              <a:rPr lang="en-US" dirty="0" smtClean="0"/>
+              <a:rPr lang="en-US" dirty="0"/>
               <a:t> occurs when the programmers </a:t>
             </a:r>
             <a:r>
-              <a:rPr lang="en-US" dirty="0" smtClean="0">
+              <a:rPr lang="en-US" dirty="0">
                 <a:solidFill>
                   <a:srgbClr val="FF0000"/>
                 </a:solidFill>
@@ -6786,7 +6725,7 @@
               <a:t>intentionally duplicate code</a:t>
             </a:r>
             <a:r>
-              <a:rPr lang="en-US" dirty="0" smtClean="0"/>
+              <a:rPr lang="en-US" dirty="0"/>
               <a:t>. They find some code that is “almost” right, so they copy-and-paste it into the new spot with some slight alterations.</a:t>
             </a:r>
           </a:p>
@@ -6797,13 +6736,6 @@
   <p:clrMapOvr>
     <a:masterClrMapping/>
   </p:clrMapOvr>
-  <p:timing>
-    <p:tnLst>
-      <p:par>
-        <p:cTn id="1" dur="indefinite" restart="never" nodeType="tmRoot"/>
-      </p:par>
-    </p:tnLst>
-  </p:timing>
 </p:sld>
 </file>
 
@@ -6840,10 +6772,10 @@
           <a:lstStyle/>
           <a:p>
             <a:r>
-              <a:rPr lang="en-US" dirty="0" smtClean="0"/>
+              <a:rPr lang="en-US" dirty="0"/>
               <a:t>Duplication</a:t>
             </a:r>
-            <a:endParaRPr lang="el-GR" dirty="0" smtClean="0"/>
+            <a:endParaRPr lang="el-GR" dirty="0"/>
           </a:p>
         </p:txBody>
       </p:sp>
@@ -6870,7 +6802,7 @@
           <a:p>
             <a:pPr algn="just"/>
             <a:r>
-              <a:rPr lang="en-US" b="1" u="sng" dirty="0" smtClean="0">
+              <a:rPr lang="en-US" b="1" u="sng" dirty="0">
                 <a:solidFill>
                   <a:srgbClr val="0070C0"/>
                 </a:solidFill>
@@ -6880,16 +6812,16 @@
           </a:p>
           <a:p>
             <a:pPr algn="just"/>
-            <a:endParaRPr lang="en-US" dirty="0" smtClean="0"/>
+            <a:endParaRPr lang="en-US" dirty="0"/>
           </a:p>
           <a:p>
             <a:pPr algn="just"/>
             <a:r>
-              <a:rPr lang="en-US" dirty="0" smtClean="0"/>
+              <a:rPr lang="en-US" dirty="0"/>
               <a:t>If the duplication occurs because a </a:t>
             </a:r>
             <a:r>
-              <a:rPr lang="en-US" b="1" dirty="0" smtClean="0">
+              <a:rPr lang="en-US" b="1" dirty="0">
                 <a:solidFill>
                   <a:srgbClr val="0070C0"/>
                 </a:solidFill>
@@ -6897,11 +6829,11 @@
               <a:t>special number</a:t>
             </a:r>
             <a:r>
-              <a:rPr lang="en-US" dirty="0" smtClean="0"/>
+              <a:rPr lang="en-US" dirty="0"/>
               <a:t>, </a:t>
             </a:r>
             <a:r>
-              <a:rPr lang="en-US" b="1" dirty="0" smtClean="0">
+              <a:rPr lang="en-US" b="1" dirty="0">
                 <a:solidFill>
                   <a:srgbClr val="0070C0"/>
                 </a:solidFill>
@@ -6909,11 +6841,11 @@
               <a:t>string,</a:t>
             </a:r>
             <a:r>
-              <a:rPr lang="en-US" dirty="0" smtClean="0"/>
+              <a:rPr lang="en-US" dirty="0"/>
               <a:t> or other </a:t>
             </a:r>
             <a:r>
-              <a:rPr lang="en-US" b="1" dirty="0" smtClean="0">
+              <a:rPr lang="en-US" b="1" dirty="0">
                 <a:solidFill>
                   <a:srgbClr val="0070C0"/>
                 </a:solidFill>
@@ -6921,11 +6853,11 @@
               <a:t>value recurs</a:t>
             </a:r>
             <a:r>
-              <a:rPr lang="en-US" dirty="0" smtClean="0"/>
+              <a:rPr lang="en-US" dirty="0"/>
               <a:t>, use </a:t>
             </a:r>
             <a:r>
-              <a:rPr lang="en-US" b="1" i="1" dirty="0" smtClean="0">
+              <a:rPr lang="en-US" b="1" i="1" dirty="0">
                 <a:solidFill>
                   <a:srgbClr val="0070C0"/>
                 </a:solidFill>
@@ -6933,7 +6865,7 @@
               <a:t>Replace Magic Number with Symbolic Constant</a:t>
             </a:r>
             <a:r>
-              <a:rPr lang="en-US" i="1" dirty="0" smtClean="0"/>
+              <a:rPr lang="en-US" i="1" dirty="0"/>
               <a:t>.</a:t>
             </a:r>
           </a:p>
@@ -6944,13 +6876,6 @@
   <p:clrMapOvr>
     <a:masterClrMapping/>
   </p:clrMapOvr>
-  <p:timing>
-    <p:tnLst>
-      <p:par>
-        <p:cTn id="1" dur="indefinite" restart="never" nodeType="tmRoot"/>
-      </p:par>
-    </p:tnLst>
-  </p:timing>
 </p:sld>
 </file>
 
@@ -6989,10 +6914,9 @@
           <a:lstStyle/>
           <a:p>
             <a:r>
-              <a:rPr lang="en-US" dirty="0" smtClean="0"/>
+              <a:rPr lang="en-US" dirty="0"/>
               <a:t>Replace Magic Number with Symbolic Constant</a:t>
             </a:r>
-            <a:endParaRPr lang="en-US" dirty="0"/>
           </a:p>
         </p:txBody>
       </p:sp>
@@ -7034,13 +6958,6 @@
   <p:clrMapOvr>
     <a:masterClrMapping/>
   </p:clrMapOvr>
-  <p:timing>
-    <p:tnLst>
-      <p:par>
-        <p:cTn id="1" dur="indefinite" restart="never" nodeType="tmRoot"/>
-      </p:par>
-    </p:tnLst>
-  </p:timing>
 </p:sld>
 </file>
 
@@ -7077,10 +6994,10 @@
           <a:lstStyle/>
           <a:p>
             <a:r>
-              <a:rPr lang="en-US" dirty="0" smtClean="0"/>
+              <a:rPr lang="en-US" dirty="0"/>
               <a:t>Duplication</a:t>
             </a:r>
-            <a:endParaRPr lang="el-GR" dirty="0" smtClean="0"/>
+            <a:endParaRPr lang="el-GR" dirty="0"/>
           </a:p>
         </p:txBody>
       </p:sp>
@@ -7107,7 +7024,7 @@
           <a:p>
             <a:pPr algn="just"/>
             <a:r>
-              <a:rPr lang="en-US" b="1" u="sng" dirty="0" smtClean="0">
+              <a:rPr lang="en-US" b="1" u="sng" dirty="0">
                 <a:solidFill>
                   <a:srgbClr val="0070C0"/>
                 </a:solidFill>
@@ -7117,16 +7034,16 @@
           </a:p>
           <a:p>
             <a:pPr algn="just"/>
-            <a:endParaRPr lang="en-US" dirty="0" smtClean="0"/>
+            <a:endParaRPr lang="en-US" dirty="0"/>
           </a:p>
           <a:p>
             <a:pPr algn="just"/>
             <a:r>
-              <a:rPr lang="en-US" dirty="0" smtClean="0"/>
+              <a:rPr lang="en-US" dirty="0"/>
               <a:t>If the duplication is within a </a:t>
             </a:r>
             <a:r>
-              <a:rPr lang="en-US" b="1" dirty="0" smtClean="0">
+              <a:rPr lang="en-US" b="1" dirty="0">
                 <a:solidFill>
                   <a:srgbClr val="0070C0"/>
                 </a:solidFill>
@@ -7134,11 +7051,11 @@
               <a:t>method</a:t>
             </a:r>
             <a:r>
-              <a:rPr lang="en-US" dirty="0" smtClean="0"/>
+              <a:rPr lang="en-US" dirty="0"/>
               <a:t> or in two</a:t>
             </a:r>
             <a:r>
-              <a:rPr lang="en-US" b="1" dirty="0" smtClean="0">
+              <a:rPr lang="en-US" b="1" dirty="0">
                 <a:solidFill>
                   <a:srgbClr val="0070C0"/>
                 </a:solidFill>
@@ -7146,23 +7063,35 @@
               <a:t> different methods </a:t>
             </a:r>
             <a:r>
-              <a:rPr lang="en-US" dirty="0" smtClean="0"/>
-              <a:t>in the same class: use </a:t>
-            </a:r>
-            <a:r>
-              <a:rPr lang="en-US" b="1" i="1" dirty="0" smtClean="0">
+              <a:rPr lang="en-US" dirty="0"/>
+              <a:t>in the </a:t>
+            </a:r>
+            <a:r>
+              <a:rPr lang="en-US" b="1" dirty="0">
                 <a:solidFill>
                   <a:srgbClr val="0070C0"/>
                 </a:solidFill>
               </a:rPr>
+              <a:t>same class:</a:t>
+            </a:r>
+            <a:r>
+              <a:rPr lang="en-US" dirty="0"/>
+              <a:t> use </a:t>
+            </a:r>
+            <a:r>
+              <a:rPr lang="en-US" b="1" i="1" dirty="0">
+                <a:solidFill>
+                  <a:srgbClr val="0070C0"/>
+                </a:solidFill>
+              </a:rPr>
               <a:t>Extract Method</a:t>
             </a:r>
             <a:r>
-              <a:rPr lang="en-US" i="1" dirty="0" smtClean="0"/>
+              <a:rPr lang="en-US" i="1" dirty="0"/>
               <a:t> and </a:t>
             </a:r>
             <a:r>
-              <a:rPr lang="en-US" b="1" i="1" dirty="0" smtClean="0">
+              <a:rPr lang="en-US" b="1" i="1" dirty="0">
                 <a:solidFill>
                   <a:srgbClr val="0070C0"/>
                 </a:solidFill>
@@ -7170,11 +7099,11 @@
               <a:t>Parameterize Method </a:t>
             </a:r>
             <a:r>
-              <a:rPr lang="en-US" i="1" dirty="0" smtClean="0"/>
+              <a:rPr lang="en-US" i="1" dirty="0"/>
               <a:t>to pull </a:t>
             </a:r>
             <a:r>
-              <a:rPr lang="en-US" i="1" dirty="0" smtClean="0">
+              <a:rPr lang="en-US" i="1" dirty="0">
                 <a:solidFill>
                   <a:srgbClr val="0070C0"/>
                 </a:solidFill>
@@ -7182,14 +7111,14 @@
               <a:t>the common/different part out into separate methods</a:t>
             </a:r>
             <a:r>
-              <a:rPr lang="en-US" i="1" dirty="0" smtClean="0"/>
+              <a:rPr lang="en-US" i="1" dirty="0"/>
               <a:t>.</a:t>
             </a:r>
           </a:p>
           <a:p>
             <a:pPr algn="just"/>
             <a:r>
-              <a:rPr lang="en-US" dirty="0" smtClean="0"/>
+              <a:rPr lang="en-US" dirty="0"/>
               <a:t> </a:t>
             </a:r>
           </a:p>
@@ -7200,13 +7129,6 @@
   <p:clrMapOvr>
     <a:masterClrMapping/>
   </p:clrMapOvr>
-  <p:timing>
-    <p:tnLst>
-      <p:par>
-        <p:cTn id="1" dur="indefinite" restart="never" nodeType="tmRoot"/>
-      </p:par>
-    </p:tnLst>
-  </p:timing>
 </p:sld>
 </file>
 
@@ -7245,10 +7167,9 @@
           <a:lstStyle/>
           <a:p>
             <a:r>
-              <a:rPr lang="en-US" dirty="0" smtClean="0"/>
+              <a:rPr lang="en-US" dirty="0"/>
               <a:t>Parameterize Method </a:t>
             </a:r>
-            <a:endParaRPr lang="en-US" dirty="0"/>
           </a:p>
         </p:txBody>
       </p:sp>
@@ -7323,13 +7244,6 @@
   <p:clrMapOvr>
     <a:masterClrMapping/>
   </p:clrMapOvr>
-  <p:timing>
-    <p:tnLst>
-      <p:par>
-        <p:cTn id="1" dur="indefinite" restart="never" nodeType="tmRoot"/>
-      </p:par>
-    </p:tnLst>
-  </p:timing>
 </p:sld>
 </file>
 
@@ -7366,10 +7280,10 @@
           <a:lstStyle/>
           <a:p>
             <a:r>
-              <a:rPr lang="en-US" dirty="0" smtClean="0"/>
+              <a:rPr lang="en-US" dirty="0"/>
               <a:t>Duplication</a:t>
             </a:r>
-            <a:endParaRPr lang="el-GR" dirty="0" smtClean="0"/>
+            <a:endParaRPr lang="el-GR" dirty="0"/>
           </a:p>
         </p:txBody>
       </p:sp>
@@ -7396,7 +7310,7 @@
           <a:p>
             <a:pPr algn="just"/>
             <a:r>
-              <a:rPr lang="en-US" b="1" u="sng" dirty="0" smtClean="0">
+              <a:rPr lang="en-US" b="1" u="sng" dirty="0">
                 <a:solidFill>
                   <a:srgbClr val="0070C0"/>
                 </a:solidFill>
@@ -7406,23 +7320,23 @@
           </a:p>
           <a:p>
             <a:pPr algn="just"/>
-            <a:endParaRPr lang="en-US" i="1" dirty="0" smtClean="0"/>
+            <a:endParaRPr lang="en-US" i="1" dirty="0"/>
           </a:p>
           <a:p>
             <a:pPr algn="just"/>
             <a:r>
-              <a:rPr lang="en-US" dirty="0" smtClean="0"/>
+              <a:rPr lang="en-US" dirty="0"/>
               <a:t> </a:t>
             </a:r>
           </a:p>
           <a:p>
             <a:pPr algn="just"/>
             <a:r>
-              <a:rPr lang="en-US" dirty="0" smtClean="0"/>
+              <a:rPr lang="en-US" dirty="0"/>
               <a:t>If the duplication is within </a:t>
             </a:r>
             <a:r>
-              <a:rPr lang="en-US" b="1" dirty="0" smtClean="0">
+              <a:rPr lang="en-US" b="1" dirty="0">
                 <a:solidFill>
                   <a:srgbClr val="0070C0"/>
                 </a:solidFill>
@@ -7430,11 +7344,11 @@
               <a:t>two sibling classes</a:t>
             </a:r>
             <a:r>
-              <a:rPr lang="en-US" dirty="0" smtClean="0"/>
+              <a:rPr lang="en-US" dirty="0"/>
               <a:t>: use </a:t>
             </a:r>
             <a:r>
-              <a:rPr lang="en-US" i="1" dirty="0" smtClean="0">
+              <a:rPr lang="en-US" i="1" dirty="0">
                 <a:solidFill>
                   <a:srgbClr val="0070C0"/>
                 </a:solidFill>
@@ -7442,11 +7356,11 @@
               <a:t>Extract Method </a:t>
             </a:r>
             <a:r>
-              <a:rPr lang="en-US" i="1" dirty="0" smtClean="0"/>
+              <a:rPr lang="en-US" i="1" dirty="0"/>
               <a:t>and </a:t>
             </a:r>
             <a:r>
-              <a:rPr lang="en-US" i="1" dirty="0" smtClean="0">
+              <a:rPr lang="en-US" i="1" dirty="0">
                 <a:solidFill>
                   <a:srgbClr val="0070C0"/>
                 </a:solidFill>
@@ -7454,15 +7368,15 @@
               <a:t>Parameterize Method </a:t>
             </a:r>
             <a:r>
-              <a:rPr lang="en-US" i="1" dirty="0" smtClean="0"/>
+              <a:rPr lang="en-US" i="1" dirty="0"/>
               <a:t>to create a </a:t>
             </a:r>
             <a:r>
-              <a:rPr lang="en-US" dirty="0" smtClean="0"/>
+              <a:rPr lang="en-US" dirty="0"/>
               <a:t>single routine, then </a:t>
             </a:r>
             <a:r>
-              <a:rPr lang="en-US" b="1" i="1" dirty="0" smtClean="0">
+              <a:rPr lang="en-US" b="1" i="1" dirty="0">
                 <a:solidFill>
                   <a:srgbClr val="0070C0"/>
                 </a:solidFill>
@@ -7470,11 +7384,11 @@
               <a:t>Pull Up Field and/or Pull Up Method </a:t>
             </a:r>
             <a:r>
-              <a:rPr lang="en-US" i="1" dirty="0" smtClean="0"/>
+              <a:rPr lang="en-US" i="1" dirty="0"/>
               <a:t>to </a:t>
             </a:r>
             <a:r>
-              <a:rPr lang="en-US" i="1" dirty="0" smtClean="0">
+              <a:rPr lang="en-US" i="1" dirty="0">
                 <a:solidFill>
                   <a:srgbClr val="0070C0"/>
                 </a:solidFill>
@@ -7482,7 +7396,7 @@
               <a:t>bring the common </a:t>
             </a:r>
             <a:r>
-              <a:rPr lang="en-US" dirty="0" smtClean="0">
+              <a:rPr lang="en-US" dirty="0">
                 <a:solidFill>
                   <a:srgbClr val="0070C0"/>
                 </a:solidFill>
@@ -7490,7 +7404,7 @@
               <a:t>parts together</a:t>
             </a:r>
             <a:r>
-              <a:rPr lang="en-US" dirty="0" smtClean="0"/>
+              <a:rPr lang="en-US" dirty="0"/>
               <a:t>. </a:t>
             </a:r>
           </a:p>
@@ -7501,13 +7415,6 @@
   <p:clrMapOvr>
     <a:masterClrMapping/>
   </p:clrMapOvr>
-  <p:timing>
-    <p:tnLst>
-      <p:par>
-        <p:cTn id="1" dur="indefinite" restart="never" nodeType="tmRoot"/>
-      </p:par>
-    </p:tnLst>
-  </p:timing>
 </p:sld>
 </file>
 
@@ -7544,10 +7451,10 @@
           <a:lstStyle/>
           <a:p>
             <a:r>
-              <a:rPr lang="en-US" dirty="0" smtClean="0"/>
+              <a:rPr lang="en-US" dirty="0"/>
               <a:t>Pull Up Field</a:t>
             </a:r>
-            <a:endParaRPr lang="el-GR" dirty="0" smtClean="0"/>
+            <a:endParaRPr lang="el-GR" dirty="0"/>
           </a:p>
         </p:txBody>
       </p:sp>
@@ -7589,13 +7496,6 @@
   <p:clrMapOvr>
     <a:masterClrMapping/>
   </p:clrMapOvr>
-  <p:timing>
-    <p:tnLst>
-      <p:par>
-        <p:cTn id="1" dur="indefinite" restart="never" nodeType="tmRoot"/>
-      </p:par>
-    </p:tnLst>
-  </p:timing>
 </p:sld>
 </file>
 

</xml_diff>